<commit_message>
Extend Review 3 to 8/10 modules: Severity Scoring, Findings Store, Remediation Generation
</commit_message>
<xml_diff>
--- a/ppt/Review3_Panel_Presentation.pptx
+++ b/ppt/Review3_Panel_Presentation.pptx
@@ -17,9 +17,10 @@
     <p:sldId id="265" r:id="rId11"/>
     <p:sldId id="266" r:id="rId12"/>
     <p:sldId id="267" r:id="rId13"/>
+    <p:sldId id="268" r:id="rId14"/>
   </p:sldIdLst>
   <p:notesMasterIdLst>
-    <p:notesMasterId r:id="rId14"/>
+    <p:notesMasterId r:id="rId15"/>
   </p:notesMasterIdLst>
   <p:sldSz cx="12192000" cy="6858000"/>
   <p:notesSz cx="6858000" cy="12192000"/>
@@ -801,6 +802,94 @@
             <a:fld id="{F7021451-1387-4CA6-816F-3879F97B5CBC}" type="slidenum">
               <a:rPr lang="en-US"/>
               <a:t>12</a:t>
+            </a:fld>
+            <a:endParaRPr lang="en-US"/>
+          </a:p>
+        </p:txBody>
+      </p:sp>
+    </p:spTree>
+    <p:extLst>
+      <p:ext uri="{BB962C8B-B14F-4D97-AF65-F5344CB8AC3E}">
+        <p14:creationId xmlns:p14="http://schemas.microsoft.com/office/powerpoint/2010/main" val="1024086991"/>
+      </p:ext>
+    </p:extLst>
+  </p:cSld>
+  <p:clrMapOvr>
+    <a:masterClrMapping/>
+  </p:clrMapOvr>
+</p:notes>
+</file>
+
+<file path=ppt/notesSlides/notesSlide13.xml><?xml version="1.0" encoding="utf-8"?>
+<p:notes xmlns:a="http://schemas.openxmlformats.org/drawingml/2006/main" xmlns:r="http://schemas.openxmlformats.org/officeDocument/2006/relationships" xmlns:p="http://schemas.openxmlformats.org/presentationml/2006/main">
+  <p:cSld>
+    <p:spTree>
+      <p:nvGrpSpPr>
+        <p:cNvPr id="1" name=""/>
+        <p:cNvGrpSpPr/>
+        <p:nvPr/>
+      </p:nvGrpSpPr>
+      <p:grpSpPr>
+        <a:xfrm>
+          <a:off x="0" y="0"/>
+          <a:ext cx="0" cy="0"/>
+          <a:chOff x="0" y="0"/>
+          <a:chExt cx="0" cy="0"/>
+        </a:xfrm>
+      </p:grpSpPr>
+      <p:sp>
+        <p:nvSpPr>
+          <p:cNvPr id="2" name="Slide Image Placeholder 1"/>
+          <p:cNvSpPr>
+            <a:spLocks noGrp="1" noRot="1" noChangeAspect="1"/>
+          </p:cNvSpPr>
+          <p:nvPr>
+            <p:ph type="sldImg"/>
+          </p:nvPr>
+        </p:nvSpPr>
+        <p:spPr/>
+      </p:sp>
+      <p:sp>
+        <p:nvSpPr>
+          <p:cNvPr id="3" name="Notes Placeholder 2"/>
+          <p:cNvSpPr>
+            <a:spLocks noGrp="1"/>
+          </p:cNvSpPr>
+          <p:nvPr>
+            <p:ph type="body" idx="1"/>
+          </p:nvPr>
+        </p:nvSpPr>
+        <p:spPr/>
+        <p:txBody>
+          <a:bodyPr/>
+          <a:lstStyle/>
+          <a:p>
+            <a:r>
+              <a:rPr lang="en-US" dirty="0"/>
+              <a:t/>
+            </a:r>
+            <a:endParaRPr lang="en-US" dirty="0"/>
+          </a:p>
+        </p:txBody>
+      </p:sp>
+      <p:sp>
+        <p:nvSpPr>
+          <p:cNvPr id="4" name="Slide Number Placeholder 3"/>
+          <p:cNvSpPr>
+            <a:spLocks noGrp="1"/>
+          </p:cNvSpPr>
+          <p:nvPr>
+            <p:ph type="sldNum" sz="quarter" idx="10"/>
+          </p:nvPr>
+        </p:nvSpPr>
+        <p:spPr/>
+        <p:txBody>
+          <a:bodyPr/>
+          <a:lstStyle/>
+          <a:p>
+            <a:fld id="{F7021451-1387-4CA6-816F-3879F97B5CBC}" type="slidenum">
+              <a:rPr lang="en-US"/>
+              <a:t>13</a:t>
             </a:fld>
             <a:endParaRPr lang="en-US"/>
           </a:p>
@@ -1863,7 +1952,7 @@
         <p:spPr>
           <a:xfrm>
             <a:off x="9692640" y="1097280"/>
-            <a:ext cx="640080" cy="3291840"/>
+            <a:ext cx="1188720" cy="822960"/>
           </a:xfrm>
           <a:prstGeom prst="line">
             <a:avLst/>
@@ -1930,9 +2019,9 @@
           <p:nvPr/>
         </p:nvSpPr>
         <p:spPr>
-          <a:xfrm flipH="1">
-            <a:off x="9144000" y="1920240"/>
-            <a:ext cx="1737360" cy="3383280"/>
+          <a:xfrm>
+            <a:off x="10881360" y="1920240"/>
+            <a:ext cx="457200" cy="1371600"/>
           </a:xfrm>
           <a:prstGeom prst="line">
             <a:avLst/>
@@ -1953,9 +2042,9 @@
           <p:nvPr/>
         </p:nvSpPr>
         <p:spPr>
-          <a:xfrm flipH="1">
-            <a:off x="10332720" y="3291840"/>
-            <a:ext cx="1005840" cy="1097280"/>
+          <a:xfrm>
+            <a:off x="10881360" y="1920240"/>
+            <a:ext cx="640080" cy="3200400"/>
           </a:xfrm>
           <a:prstGeom prst="line">
             <a:avLst/>
@@ -1977,8 +2066,8 @@
         </p:nvSpPr>
         <p:spPr>
           <a:xfrm>
-            <a:off x="11338560" y="3291840"/>
-            <a:ext cx="182880" cy="1828800"/>
+            <a:off x="9326880" y="2377440"/>
+            <a:ext cx="2011680" cy="914400"/>
           </a:xfrm>
           <a:prstGeom prst="line">
             <a:avLst/>
@@ -1999,9 +2088,9 @@
           <p:nvPr/>
         </p:nvSpPr>
         <p:spPr>
-          <a:xfrm>
-            <a:off x="8778240" y="3749040"/>
-            <a:ext cx="2743200" cy="1371600"/>
+          <a:xfrm flipH="1">
+            <a:off x="8778240" y="2377440"/>
+            <a:ext cx="548640" cy="1371600"/>
           </a:xfrm>
           <a:prstGeom prst="line">
             <a:avLst/>
@@ -2023,6 +2112,121 @@
         </p:nvSpPr>
         <p:spPr>
           <a:xfrm>
+            <a:off x="9326880" y="2377440"/>
+            <a:ext cx="2194560" cy="2743200"/>
+          </a:xfrm>
+          <a:prstGeom prst="line">
+            <a:avLst/>
+          </a:prstGeom>
+          <a:noFill/>
+          <a:ln w="12700">
+            <a:solidFill>
+              <a:srgbClr val="3A5A8C"/>
+            </a:solidFill>
+            <a:prstDash val="solid"/>
+          </a:ln>
+        </p:spPr>
+      </p:sp>
+      <p:sp>
+        <p:nvSpPr>
+          <p:cNvPr id="10" name="Shape 8"/>
+          <p:cNvSpPr/>
+          <p:nvPr/>
+        </p:nvSpPr>
+        <p:spPr>
+          <a:xfrm flipH="1">
+            <a:off x="10332720" y="3291840"/>
+            <a:ext cx="1005840" cy="1097280"/>
+          </a:xfrm>
+          <a:prstGeom prst="line">
+            <a:avLst/>
+          </a:prstGeom>
+          <a:noFill/>
+          <a:ln w="12700">
+            <a:solidFill>
+              <a:srgbClr val="3A5A8C"/>
+            </a:solidFill>
+            <a:prstDash val="solid"/>
+          </a:ln>
+        </p:spPr>
+      </p:sp>
+      <p:sp>
+        <p:nvSpPr>
+          <p:cNvPr id="11" name="Shape 9"/>
+          <p:cNvSpPr/>
+          <p:nvPr/>
+        </p:nvSpPr>
+        <p:spPr>
+          <a:xfrm>
+            <a:off x="8778240" y="3749040"/>
+            <a:ext cx="365760" cy="1554480"/>
+          </a:xfrm>
+          <a:prstGeom prst="line">
+            <a:avLst/>
+          </a:prstGeom>
+          <a:noFill/>
+          <a:ln w="12700">
+            <a:solidFill>
+              <a:srgbClr val="3A5A8C"/>
+            </a:solidFill>
+            <a:prstDash val="solid"/>
+          </a:ln>
+        </p:spPr>
+      </p:sp>
+      <p:sp>
+        <p:nvSpPr>
+          <p:cNvPr id="12" name="Shape 10"/>
+          <p:cNvSpPr/>
+          <p:nvPr/>
+        </p:nvSpPr>
+        <p:spPr>
+          <a:xfrm>
+            <a:off x="8778240" y="3749040"/>
+            <a:ext cx="2743200" cy="1371600"/>
+          </a:xfrm>
+          <a:prstGeom prst="line">
+            <a:avLst/>
+          </a:prstGeom>
+          <a:noFill/>
+          <a:ln w="12700">
+            <a:solidFill>
+              <a:srgbClr val="3A5A8C"/>
+            </a:solidFill>
+            <a:prstDash val="solid"/>
+          </a:ln>
+        </p:spPr>
+      </p:sp>
+      <p:sp>
+        <p:nvSpPr>
+          <p:cNvPr id="13" name="Shape 11"/>
+          <p:cNvSpPr/>
+          <p:nvPr/>
+        </p:nvSpPr>
+        <p:spPr>
+          <a:xfrm>
+            <a:off x="10332720" y="4389120"/>
+            <a:ext cx="1188720" cy="731520"/>
+          </a:xfrm>
+          <a:prstGeom prst="line">
+            <a:avLst/>
+          </a:prstGeom>
+          <a:noFill/>
+          <a:ln w="12700">
+            <a:solidFill>
+              <a:srgbClr val="3A5A8C"/>
+            </a:solidFill>
+            <a:prstDash val="solid"/>
+          </a:ln>
+        </p:spPr>
+      </p:sp>
+      <p:sp>
+        <p:nvSpPr>
+          <p:cNvPr id="14" name="Shape 12"/>
+          <p:cNvSpPr/>
+          <p:nvPr/>
+        </p:nvSpPr>
+        <p:spPr>
+          <a:xfrm>
             <a:off x="9610344" y="1014984"/>
             <a:ext cx="164592" cy="164592"/>
           </a:xfrm>
@@ -2037,7 +2241,7 @@
       </p:sp>
       <p:sp>
         <p:nvSpPr>
-          <p:cNvPr id="10" name="Shape 8"/>
+          <p:cNvPr id="15" name="Shape 13"/>
           <p:cNvSpPr/>
           <p:nvPr/>
         </p:nvSpPr>
@@ -2057,7 +2261,7 @@
       </p:sp>
       <p:sp>
         <p:nvSpPr>
-          <p:cNvPr id="11" name="Shape 9"/>
+          <p:cNvPr id="16" name="Shape 14"/>
           <p:cNvSpPr/>
           <p:nvPr/>
         </p:nvSpPr>
@@ -2077,7 +2281,7 @@
       </p:sp>
       <p:sp>
         <p:nvSpPr>
-          <p:cNvPr id="12" name="Shape 10"/>
+          <p:cNvPr id="17" name="Shape 15"/>
           <p:cNvSpPr/>
           <p:nvPr/>
         </p:nvSpPr>
@@ -2097,7 +2301,7 @@
       </p:sp>
       <p:sp>
         <p:nvSpPr>
-          <p:cNvPr id="13" name="Shape 11"/>
+          <p:cNvPr id="18" name="Shape 16"/>
           <p:cNvSpPr/>
           <p:nvPr/>
         </p:nvSpPr>
@@ -2117,7 +2321,7 @@
       </p:sp>
       <p:sp>
         <p:nvSpPr>
-          <p:cNvPr id="14" name="Shape 12"/>
+          <p:cNvPr id="19" name="Shape 17"/>
           <p:cNvSpPr/>
           <p:nvPr/>
         </p:nvSpPr>
@@ -2137,7 +2341,7 @@
       </p:sp>
       <p:sp>
         <p:nvSpPr>
-          <p:cNvPr id="15" name="Shape 13"/>
+          <p:cNvPr id="20" name="Shape 18"/>
           <p:cNvSpPr/>
           <p:nvPr/>
         </p:nvSpPr>
@@ -2157,7 +2361,7 @@
       </p:sp>
       <p:sp>
         <p:nvSpPr>
-          <p:cNvPr id="16" name="Shape 14"/>
+          <p:cNvPr id="21" name="Shape 19"/>
           <p:cNvSpPr/>
           <p:nvPr/>
         </p:nvSpPr>
@@ -2177,7 +2381,7 @@
       </p:sp>
       <p:sp>
         <p:nvSpPr>
-          <p:cNvPr id="17" name="Text 15"/>
+          <p:cNvPr id="22" name="Text 20"/>
           <p:cNvSpPr/>
           <p:nvPr/>
         </p:nvSpPr>
@@ -2216,7 +2420,7 @@
       </p:sp>
       <p:sp>
         <p:nvSpPr>
-          <p:cNvPr id="18" name="Text 16"/>
+          <p:cNvPr id="23" name="Text 21"/>
           <p:cNvSpPr/>
           <p:nvPr/>
         </p:nvSpPr>
@@ -2298,7 +2502,7 @@
       </p:sp>
       <p:sp>
         <p:nvSpPr>
-          <p:cNvPr id="19" name="Text 17"/>
+          <p:cNvPr id="24" name="Text 22"/>
           <p:cNvSpPr/>
           <p:nvPr/>
         </p:nvSpPr>
@@ -2337,14 +2541,14 @@
       </p:sp>
       <p:sp>
         <p:nvSpPr>
-          <p:cNvPr id="20" name="Shape 18"/>
+          <p:cNvPr id="25" name="Shape 23"/>
           <p:cNvSpPr/>
           <p:nvPr/>
         </p:nvSpPr>
         <p:spPr>
           <a:xfrm>
             <a:off x="640080" y="4251960"/>
-            <a:ext cx="4114800" cy="365760"/>
+            <a:ext cx="4297680" cy="365760"/>
           </a:xfrm>
           <a:prstGeom prst="roundRect">
             <a:avLst>
@@ -2359,14 +2563,14 @@
       </p:sp>
       <p:sp>
         <p:nvSpPr>
-          <p:cNvPr id="21" name="Text 19"/>
+          <p:cNvPr id="26" name="Text 24"/>
           <p:cNvSpPr/>
           <p:nvPr/>
         </p:nvSpPr>
         <p:spPr>
           <a:xfrm>
             <a:off x="640080" y="4251960"/>
-            <a:ext cx="4114800" cy="365760"/>
+            <a:ext cx="4297680" cy="365760"/>
           </a:xfrm>
           <a:prstGeom prst="rect">
             <a:avLst/>
@@ -2390,7 +2594,7 @@
                 <a:ea typeface="Calibri" pitchFamily="34" charset="-122"/>
                 <a:cs typeface="Calibri" pitchFamily="34" charset="-120"/>
               </a:rPr>
-              <a:t>5 / 10 modules implemented · running end-to-end</a:t>
+              <a:t>8 / 10 modules implemented · running end-to-end</a:t>
             </a:r>
             <a:endParaRPr lang="en-US" sz="1150" dirty="0"/>
           </a:p>
@@ -2398,7 +2602,7 @@
       </p:sp>
       <p:sp>
         <p:nvSpPr>
-          <p:cNvPr id="22" name="Shape 20"/>
+          <p:cNvPr id="27" name="Shape 25"/>
           <p:cNvSpPr/>
           <p:nvPr/>
         </p:nvSpPr>
@@ -2418,7 +2622,7 @@
       </p:sp>
       <p:sp>
         <p:nvSpPr>
-          <p:cNvPr id="23" name="Text 21"/>
+          <p:cNvPr id="28" name="Text 26"/>
           <p:cNvSpPr/>
           <p:nvPr/>
         </p:nvSpPr>
@@ -2500,7 +2704,7 @@
       </p:sp>
       <p:sp>
         <p:nvSpPr>
-          <p:cNvPr id="24" name="Text 22"/>
+          <p:cNvPr id="29" name="Text 27"/>
           <p:cNvSpPr/>
           <p:nvPr/>
         </p:nvSpPr>
@@ -2553,7 +2757,7 @@
       </p:sp>
       <p:sp>
         <p:nvSpPr>
-          <p:cNvPr id="25" name="Text 23"/>
+          <p:cNvPr id="30" name="Text 28"/>
           <p:cNvSpPr/>
           <p:nvPr/>
         </p:nvSpPr>
@@ -2601,6 +2805,424 @@
 <file path=ppt/slides/slide10.xml><?xml version="1.0" encoding="utf-8"?>
 <p:sld xmlns:a="http://schemas.openxmlformats.org/drawingml/2006/main" xmlns:r="http://schemas.openxmlformats.org/officeDocument/2006/relationships" xmlns:p="http://schemas.openxmlformats.org/presentationml/2006/main">
   <p:cSld name="Slide 10">
+    <p:bg>
+      <p:bgPr>
+        <a:solidFill>
+          <a:srgbClr val="FFFFFF"/>
+        </a:solidFill>
+      </p:bgPr>
+    </p:bg>
+    <p:spTree>
+      <p:nvGrpSpPr>
+        <p:cNvPr id="1" name=""/>
+        <p:cNvGrpSpPr/>
+        <p:nvPr/>
+      </p:nvGrpSpPr>
+      <p:grpSpPr>
+        <a:xfrm>
+          <a:off x="0" y="0"/>
+          <a:ext cx="0" cy="0"/>
+          <a:chOff x="0" y="0"/>
+          <a:chExt cx="0" cy="0"/>
+        </a:xfrm>
+      </p:grpSpPr>
+      <p:sp>
+        <p:nvSpPr>
+          <p:cNvPr id="2" name="Text 0"/>
+          <p:cNvSpPr/>
+          <p:nvPr/>
+        </p:nvSpPr>
+        <p:spPr>
+          <a:xfrm>
+            <a:off x="548640" y="320040"/>
+            <a:ext cx="10972800" cy="320040"/>
+          </a:xfrm>
+          <a:prstGeom prst="rect">
+            <a:avLst/>
+          </a:prstGeom>
+          <a:noFill/>
+          <a:ln/>
+        </p:spPr>
+        <p:txBody>
+          <a:bodyPr wrap="square" rtlCol="0" anchor="ctr"/>
+          <a:lstStyle/>
+          <a:p>
+            <a:pPr indent="0" marL="0">
+              <a:buNone/>
+            </a:pPr>
+            <a:r>
+              <a:rPr lang="en-US" sz="1200" b="1" spc="100" kern="0" dirty="0">
+                <a:solidFill>
+                  <a:srgbClr val="1C7293"/>
+                </a:solidFill>
+                <a:latin typeface="Calibri" pitchFamily="34" charset="0"/>
+                <a:ea typeface="Calibri" pitchFamily="34" charset="-122"/>
+                <a:cs typeface="Calibri" pitchFamily="34" charset="-120"/>
+              </a:rPr>
+              <a:t>5 · RESULTS SO FAR</a:t>
+            </a:r>
+            <a:endParaRPr lang="en-US" sz="1200" dirty="0"/>
+          </a:p>
+        </p:txBody>
+      </p:sp>
+      <p:sp>
+        <p:nvSpPr>
+          <p:cNvPr id="3" name="Text 1"/>
+          <p:cNvSpPr/>
+          <p:nvPr/>
+        </p:nvSpPr>
+        <p:spPr>
+          <a:xfrm>
+            <a:off x="548640" y="621792"/>
+            <a:ext cx="11064240" cy="822960"/>
+          </a:xfrm>
+          <a:prstGeom prst="rect">
+            <a:avLst/>
+          </a:prstGeom>
+          <a:noFill/>
+          <a:ln/>
+        </p:spPr>
+        <p:txBody>
+          <a:bodyPr wrap="square" rtlCol="0" anchor="ctr"/>
+          <a:lstStyle/>
+          <a:p>
+            <a:pPr indent="0" marL="0">
+              <a:buNone/>
+            </a:pPr>
+            <a:r>
+              <a:rPr lang="en-US" sz="2800" b="1" dirty="0">
+                <a:solidFill>
+                  <a:srgbClr val="21295C"/>
+                </a:solidFill>
+                <a:latin typeface="Cambria" pitchFamily="34" charset="0"/>
+                <a:ea typeface="Cambria" pitchFamily="34" charset="-122"/>
+                <a:cs typeface="Cambria" pitchFamily="34" charset="-120"/>
+              </a:rPr>
+              <a:t>Retrieval-Accuracy Benchmark (22 Labeled Snippets)</a:t>
+            </a:r>
+            <a:endParaRPr lang="en-US" sz="2800" dirty="0"/>
+          </a:p>
+        </p:txBody>
+      </p:sp>
+      <p:pic>
+        <p:nvPicPr>
+          <p:cNvPr id="4" name="Image 0" descr="../results/benchmark_accuracy.png">    </p:cNvPr>
+          <p:cNvPicPr>
+            <a:picLocks noChangeAspect="1"/>
+          </p:cNvPicPr>
+          <p:nvPr/>
+        </p:nvPicPr>
+        <p:blipFill>
+          <a:blip r:embed="rId1"/>
+          <a:stretch>
+            <a:fillRect/>
+          </a:stretch>
+        </p:blipFill>
+        <p:spPr>
+          <a:xfrm>
+            <a:off x="548640" y="1371600"/>
+            <a:ext cx="5943600" cy="4160520"/>
+          </a:xfrm>
+          <a:prstGeom prst="rect">
+            <a:avLst/>
+          </a:prstGeom>
+        </p:spPr>
+      </p:pic>
+      <p:sp>
+        <p:nvSpPr>
+          <p:cNvPr id="5" name="Shape 2"/>
+          <p:cNvSpPr/>
+          <p:nvPr/>
+        </p:nvSpPr>
+        <p:spPr>
+          <a:xfrm>
+            <a:off x="6766560" y="1371600"/>
+            <a:ext cx="4892040" cy="1920240"/>
+          </a:xfrm>
+          <a:prstGeom prst="roundRect">
+            <a:avLst>
+              <a:gd name="adj" fmla="val 3810"/>
+            </a:avLst>
+          </a:prstGeom>
+          <a:solidFill>
+            <a:srgbClr val="EAF3F8"/>
+          </a:solidFill>
+          <a:ln/>
+        </p:spPr>
+      </p:sp>
+      <p:sp>
+        <p:nvSpPr>
+          <p:cNvPr id="6" name="Text 3"/>
+          <p:cNvSpPr/>
+          <p:nvPr/>
+        </p:nvSpPr>
+        <p:spPr>
+          <a:xfrm>
+            <a:off x="6995160" y="1508760"/>
+            <a:ext cx="4480560" cy="640080"/>
+          </a:xfrm>
+          <a:prstGeom prst="rect">
+            <a:avLst/>
+          </a:prstGeom>
+          <a:noFill/>
+          <a:ln/>
+        </p:spPr>
+        <p:txBody>
+          <a:bodyPr wrap="square" rtlCol="0" anchor="ctr"/>
+          <a:lstStyle/>
+          <a:p>
+            <a:pPr indent="0" marL="0">
+              <a:buNone/>
+            </a:pPr>
+            <a:r>
+              <a:rPr lang="en-US" sz="2800" b="1" dirty="0">
+                <a:solidFill>
+                  <a:srgbClr val="065A82"/>
+                </a:solidFill>
+                <a:latin typeface="Cambria" pitchFamily="34" charset="0"/>
+                <a:ea typeface="Cambria" pitchFamily="34" charset="-122"/>
+                <a:cs typeface="Cambria" pitchFamily="34" charset="-120"/>
+              </a:rPr>
+              <a:t>63.6% / 72.7%</a:t>
+            </a:r>
+            <a:endParaRPr lang="en-US" sz="2800" dirty="0"/>
+          </a:p>
+        </p:txBody>
+      </p:sp>
+      <p:sp>
+        <p:nvSpPr>
+          <p:cNvPr id="7" name="Text 4"/>
+          <p:cNvSpPr/>
+          <p:nvPr/>
+        </p:nvSpPr>
+        <p:spPr>
+          <a:xfrm>
+            <a:off x="6995160" y="2148840"/>
+            <a:ext cx="4480560" cy="1005840"/>
+          </a:xfrm>
+          <a:prstGeom prst="rect">
+            <a:avLst/>
+          </a:prstGeom>
+          <a:noFill/>
+          <a:ln/>
+        </p:spPr>
+        <p:txBody>
+          <a:bodyPr wrap="square" rtlCol="0" anchor="ctr"/>
+          <a:lstStyle/>
+          <a:p>
+            <a:pPr indent="0" marL="0">
+              <a:lnSpc>
+                <a:spcPct val="125000"/>
+              </a:lnSpc>
+              <a:buNone/>
+            </a:pPr>
+            <a:r>
+              <a:rPr lang="en-US" sz="1150" dirty="0">
+                <a:solidFill>
+                  <a:srgbClr val="333F4E"/>
+                </a:solidFill>
+                <a:latin typeface="Calibri" pitchFamily="34" charset="0"/>
+                <a:ea typeface="Calibri" pitchFamily="34" charset="-122"/>
+                <a:cs typeface="Calibri" pitchFamily="34" charset="-120"/>
+              </a:rPr>
+              <a:t>Top-1 / Top-3 retrieval accuracy against ground-truth CWE labels, using the IDF-weighted embedding actually shipped in the pipeline</a:t>
+            </a:r>
+            <a:endParaRPr lang="en-US" sz="1150" dirty="0"/>
+          </a:p>
+        </p:txBody>
+      </p:sp>
+      <p:sp>
+        <p:nvSpPr>
+          <p:cNvPr id="8" name="Shape 5"/>
+          <p:cNvSpPr/>
+          <p:nvPr/>
+        </p:nvSpPr>
+        <p:spPr>
+          <a:xfrm>
+            <a:off x="6766560" y="3520440"/>
+            <a:ext cx="4892040" cy="2011680"/>
+          </a:xfrm>
+          <a:prstGeom prst="roundRect">
+            <a:avLst>
+              <a:gd name="adj" fmla="val 3636"/>
+            </a:avLst>
+          </a:prstGeom>
+          <a:solidFill>
+            <a:srgbClr val="FBEDE8"/>
+          </a:solidFill>
+          <a:ln/>
+        </p:spPr>
+      </p:sp>
+      <p:sp>
+        <p:nvSpPr>
+          <p:cNvPr id="9" name="Text 6"/>
+          <p:cNvSpPr/>
+          <p:nvPr/>
+        </p:nvSpPr>
+        <p:spPr>
+          <a:xfrm>
+            <a:off x="6995160" y="3657600"/>
+            <a:ext cx="4480560" cy="320040"/>
+          </a:xfrm>
+          <a:prstGeom prst="rect">
+            <a:avLst/>
+          </a:prstGeom>
+          <a:noFill/>
+          <a:ln/>
+        </p:spPr>
+        <p:txBody>
+          <a:bodyPr wrap="square" rtlCol="0" anchor="ctr"/>
+          <a:lstStyle/>
+          <a:p>
+            <a:pPr indent="0" marL="0">
+              <a:buNone/>
+            </a:pPr>
+            <a:r>
+              <a:rPr lang="en-US" sz="1250" b="1" dirty="0">
+                <a:solidFill>
+                  <a:srgbClr val="B03A2E"/>
+                </a:solidFill>
+                <a:latin typeface="Calibri" pitchFamily="34" charset="0"/>
+                <a:ea typeface="Calibri" pitchFamily="34" charset="-122"/>
+                <a:cs typeface="Calibri" pitchFamily="34" charset="-120"/>
+              </a:rPr>
+              <a:t>Where it still struggles</a:t>
+            </a:r>
+            <a:endParaRPr lang="en-US" sz="1250" dirty="0"/>
+          </a:p>
+        </p:txBody>
+      </p:sp>
+      <p:sp>
+        <p:nvSpPr>
+          <p:cNvPr id="10" name="Text 7"/>
+          <p:cNvSpPr/>
+          <p:nvPr/>
+        </p:nvSpPr>
+        <p:spPr>
+          <a:xfrm>
+            <a:off x="6995160" y="4023360"/>
+            <a:ext cx="4480560" cy="1417320"/>
+          </a:xfrm>
+          <a:prstGeom prst="rect">
+            <a:avLst/>
+          </a:prstGeom>
+          <a:noFill/>
+          <a:ln/>
+        </p:spPr>
+        <p:txBody>
+          <a:bodyPr wrap="square" rtlCol="0" anchor="ctr"/>
+          <a:lstStyle/>
+          <a:p>
+            <a:pPr indent="0" marL="0">
+              <a:lnSpc>
+                <a:spcPct val="120000"/>
+              </a:lnSpc>
+              <a:buNone/>
+            </a:pPr>
+            <a:r>
+              <a:rPr lang="en-US" sz="1050" dirty="0">
+                <a:solidFill>
+                  <a:srgbClr val="333F4E"/>
+                </a:solidFill>
+                <a:latin typeface="Calibri" pitchFamily="34" charset="0"/>
+                <a:ea typeface="Calibri" pitchFamily="34" charset="-122"/>
+                <a:cs typeface="Calibri" pitchFamily="34" charset="-120"/>
+              </a:rPr>
+              <a:t>Closely related access-control weaknesses (Missing/Incorrect Authorization, IDOR, Broken Access Control) — these differ on facts a word-frequency model can't see (is a check present at all, or present but wrong?). This is the specific, motivated target for the Review 4 LLM reasoning step, and the same family drives most of this sprint's low_confidence severity flags (slide 8).</a:t>
+            </a:r>
+            <a:endParaRPr lang="en-US" sz="1050" dirty="0"/>
+          </a:p>
+        </p:txBody>
+      </p:sp>
+      <p:sp>
+        <p:nvSpPr>
+          <p:cNvPr id="11" name="Text 8"/>
+          <p:cNvSpPr/>
+          <p:nvPr/>
+        </p:nvSpPr>
+        <p:spPr>
+          <a:xfrm>
+            <a:off x="457200" y="6492240"/>
+            <a:ext cx="5486400" cy="274320"/>
+          </a:xfrm>
+          <a:prstGeom prst="rect">
+            <a:avLst/>
+          </a:prstGeom>
+          <a:noFill/>
+          <a:ln/>
+        </p:spPr>
+        <p:txBody>
+          <a:bodyPr wrap="square" rtlCol="0" anchor="ctr"/>
+          <a:lstStyle/>
+          <a:p>
+            <a:pPr algn="l" indent="0" marL="0">
+              <a:buNone/>
+            </a:pPr>
+            <a:r>
+              <a:rPr lang="en-US" sz="900" dirty="0">
+                <a:solidFill>
+                  <a:srgbClr val="5B6472"/>
+                </a:solidFill>
+                <a:latin typeface="Calibri" pitchFamily="34" charset="0"/>
+                <a:ea typeface="Calibri" pitchFamily="34" charset="-122"/>
+                <a:cs typeface="Calibri" pitchFamily="34" charset="-120"/>
+              </a:rPr>
+              <a:t>BCSE497J · Project I · Review 3</a:t>
+            </a:r>
+            <a:endParaRPr lang="en-US" sz="900" dirty="0"/>
+          </a:p>
+        </p:txBody>
+      </p:sp>
+      <p:sp>
+        <p:nvSpPr>
+          <p:cNvPr id="12" name="Text 9"/>
+          <p:cNvSpPr/>
+          <p:nvPr/>
+        </p:nvSpPr>
+        <p:spPr>
+          <a:xfrm>
+            <a:off x="11274552" y="6492240"/>
+            <a:ext cx="457200" cy="274320"/>
+          </a:xfrm>
+          <a:prstGeom prst="rect">
+            <a:avLst/>
+          </a:prstGeom>
+          <a:noFill/>
+          <a:ln/>
+        </p:spPr>
+        <p:txBody>
+          <a:bodyPr wrap="square" rtlCol="0" anchor="ctr"/>
+          <a:lstStyle/>
+          <a:p>
+            <a:pPr algn="r" indent="0" marL="0">
+              <a:buNone/>
+            </a:pPr>
+            <a:r>
+              <a:rPr lang="en-US" sz="900" dirty="0">
+                <a:solidFill>
+                  <a:srgbClr val="5B6472"/>
+                </a:solidFill>
+                <a:latin typeface="Calibri" pitchFamily="34" charset="0"/>
+                <a:ea typeface="Calibri" pitchFamily="34" charset="-122"/>
+                <a:cs typeface="Calibri" pitchFamily="34" charset="-120"/>
+              </a:rPr>
+              <a:t>10</a:t>
+            </a:r>
+            <a:endParaRPr lang="en-US" sz="900" dirty="0"/>
+          </a:p>
+        </p:txBody>
+      </p:sp>
+    </p:spTree>
+  </p:cSld>
+  <p:clrMapOvr>
+    <a:masterClrMapping/>
+  </p:clrMapOvr>
+</p:sld>
+</file>
+
+<file path=ppt/slides/slide11.xml><?xml version="1.0" encoding="utf-8"?>
+<p:sld xmlns:a="http://schemas.openxmlformats.org/drawingml/2006/main" xmlns:r="http://schemas.openxmlformats.org/officeDocument/2006/relationships" xmlns:p="http://schemas.openxmlformats.org/presentationml/2006/main">
+  <p:cSld name="Slide 11">
     <p:bg>
       <p:bgPr>
         <a:solidFill>
@@ -2747,7 +3369,7 @@
               <a:buNone/>
             </a:pPr>
             <a:r>
-              <a:rPr lang="en-US" sz="4600" b="1" dirty="0">
+              <a:rPr lang="en-US" sz="4200" b="1" dirty="0">
                 <a:solidFill>
                   <a:srgbClr val="8FD3E8"/>
                 </a:solidFill>
@@ -2755,9 +3377,9 @@
                 <a:ea typeface="Cambria" pitchFamily="34" charset="-122"/>
                 <a:cs typeface="Cambria" pitchFamily="34" charset="-120"/>
               </a:rPr>
-              <a:t>7 / 7</a:t>
-            </a:r>
-            <a:endParaRPr lang="en-US" sz="4600" dirty="0"/>
+              <a:t>32 / 32</a:t>
+            </a:r>
+            <a:endParaRPr lang="en-US" sz="4200" dirty="0"/>
           </a:p>
         </p:txBody>
       </p:sp>
@@ -2833,7 +3455,7 @@
                 <a:ea typeface="Calibri" pitchFamily="34" charset="-122"/>
                 <a:cs typeface="Calibri" pitchFamily="34" charset="-120"/>
               </a:rPr>
-              <a:t>pytest · src/tests/test_pipeline.py</a:t>
+              <a:t>pytest · src/tests/ (4 files, 1 per module group)</a:t>
             </a:r>
             <a:endParaRPr lang="en-US" sz="1050" dirty="0"/>
           </a:p>
@@ -2865,13 +3487,13 @@
                 <a:spcPct val="135000"/>
               </a:lnSpc>
               <a:spcAft>
-                <a:spcPts val="1000"/>
+                <a:spcPts val="1200"/>
               </a:spcAft>
               <a:buSzPct val="100000"/>
               <a:buChar char="✓"/>
             </a:pPr>
             <a:r>
-              <a:rPr lang="en-US" sz="1300" dirty="0">
+              <a:rPr lang="en-US" sz="1250" dirty="0">
                 <a:solidFill>
                   <a:srgbClr val="E4ECF7"/>
                 </a:solidFill>
@@ -2879,9 +3501,9 @@
                 <a:ea typeface="Calibri" pitchFamily="34" charset="-122"/>
                 <a:cs typeface="Calibri" pitchFamily="34" charset="-120"/>
               </a:rPr>
-              <a:t>Python &amp; JavaScript chunkers correctly identify function/class boundaries and names</a:t>
-            </a:r>
-            <a:endParaRPr lang="en-US" sz="1300" dirty="0"/>
+              <a:t>Chunkers, tokenizer, embeddings, FAISS round-trip, KB load &amp; SQLi retrieval (7 tests, unchanged)</a:t>
+            </a:r>
+            <a:endParaRPr lang="en-US" sz="1250" dirty="0"/>
           </a:p>
           <a:p>
             <a:pPr marL="342900" indent="-342900">
@@ -2889,13 +3511,13 @@
                 <a:spcPct val="135000"/>
               </a:lnSpc>
               <a:spcAft>
-                <a:spcPts val="1000"/>
+                <a:spcPts val="1200"/>
               </a:spcAft>
               <a:buSzPct val="100000"/>
               <a:buChar char="✓"/>
             </a:pPr>
             <a:r>
-              <a:rPr lang="en-US" sz="1300" dirty="0">
+              <a:rPr lang="en-US" sz="1250" dirty="0">
                 <a:solidFill>
                   <a:srgbClr val="E4ECF7"/>
                 </a:solidFill>
@@ -2903,9 +3525,9 @@
                 <a:ea typeface="Calibri" pitchFamily="34" charset="-122"/>
                 <a:cs typeface="Calibri" pitchFamily="34" charset="-120"/>
               </a:rPr>
-              <a:t>Identifier tokenizer correctly splits camelCase and snake_case</a:t>
-            </a:r>
-            <a:endParaRPr lang="en-US" sz="1300" dirty="0"/>
+              <a:t>Severity: band/score lookup, margin-threshold downgrade, confidence flagging (10 tests, new)</a:t>
+            </a:r>
+            <a:endParaRPr lang="en-US" sz="1250" dirty="0"/>
           </a:p>
           <a:p>
             <a:pPr marL="342900" indent="-342900">
@@ -2913,13 +3535,13 @@
                 <a:spcPct val="135000"/>
               </a:lnSpc>
               <a:spcAft>
-                <a:spcPts val="1000"/>
+                <a:spcPts val="1200"/>
               </a:spcAft>
               <a:buSzPct val="100000"/>
               <a:buChar char="✓"/>
             </a:pPr>
             <a:r>
-              <a:rPr lang="en-US" sz="1300" dirty="0">
+              <a:rPr lang="en-US" sz="1250" dirty="0">
                 <a:solidFill>
                   <a:srgbClr val="E4ECF7"/>
                 </a:solidFill>
@@ -2927,9 +3549,9 @@
                 <a:ea typeface="Calibri" pitchFamily="34" charset="-122"/>
                 <a:cs typeface="Calibri" pitchFamily="34" charset="-120"/>
               </a:rPr>
-              <a:t>Embeddings are unit-normalised (L2 norm = 1)</a:t>
-            </a:r>
-            <a:endParaRPr lang="en-US" sz="1300" dirty="0"/>
+              <a:t>Findings Store: schema, insert/query, filtering, per-severity counts, per-repo delete (7 tests, new)</a:t>
+            </a:r>
+            <a:endParaRPr lang="en-US" sz="1250" dirty="0"/>
           </a:p>
           <a:p>
             <a:pPr marL="342900" indent="-342900">
@@ -2937,13 +3559,13 @@
                 <a:spcPct val="135000"/>
               </a:lnSpc>
               <a:spcAft>
-                <a:spcPts val="1000"/>
+                <a:spcPts val="1200"/>
               </a:spcAft>
               <a:buSzPct val="100000"/>
               <a:buChar char="✓"/>
             </a:pPr>
             <a:r>
-              <a:rPr lang="en-US" sz="1300" dirty="0">
+              <a:rPr lang="en-US" sz="1250" dirty="0">
                 <a:solidFill>
                   <a:srgbClr val="E4ECF7"/>
                 </a:solidFill>
@@ -2951,133 +3573,85 @@
                 <a:ea typeface="Calibri" pitchFamily="34" charset="-122"/>
                 <a:cs typeface="Calibri" pitchFamily="34" charset="-120"/>
               </a:rPr>
-              <a:t>FAISS vector store save/load round-trip preserves vectors and metadata</a:t>
-            </a:r>
-            <a:endParaRPr lang="en-US" sz="1300" dirty="0"/>
-          </a:p>
-          <a:p>
-            <a:pPr marL="342900" indent="-342900">
-              <a:lnSpc>
-                <a:spcPct val="135000"/>
-              </a:lnSpc>
-              <a:spcAft>
-                <a:spcPts val="1000"/>
-              </a:spcAft>
-              <a:buSzPct val="100000"/>
-              <a:buChar char="✓"/>
-            </a:pPr>
-            <a:r>
-              <a:rPr lang="en-US" sz="1300" dirty="0">
-                <a:solidFill>
-                  <a:srgbClr val="E4ECF7"/>
+              <a:t>Remediation: 7 templated CWEs produce real before/after diffs; unknown/no-template CWEs return None (8 tests, new)</a:t>
+            </a:r>
+            <a:endParaRPr lang="en-US" sz="1250" dirty="0"/>
+          </a:p>
+        </p:txBody>
+      </p:sp>
+      <p:sp>
+        <p:nvSpPr>
+          <p:cNvPr id="9" name="Text 7"/>
+          <p:cNvSpPr/>
+          <p:nvPr/>
+        </p:nvSpPr>
+        <p:spPr>
+          <a:xfrm>
+            <a:off x="457200" y="6492240"/>
+            <a:ext cx="5486400" cy="274320"/>
+          </a:xfrm>
+          <a:prstGeom prst="rect">
+            <a:avLst/>
+          </a:prstGeom>
+          <a:noFill/>
+          <a:ln/>
+        </p:spPr>
+        <p:txBody>
+          <a:bodyPr wrap="square" rtlCol="0" anchor="ctr"/>
+          <a:lstStyle/>
+          <a:p>
+            <a:pPr algn="l" indent="0" marL="0">
+              <a:buNone/>
+            </a:pPr>
+            <a:r>
+              <a:rPr lang="en-US" sz="900" dirty="0">
+                <a:solidFill>
+                  <a:srgbClr val="B9C4D6"/>
                 </a:solidFill>
                 <a:latin typeface="Calibri" pitchFamily="34" charset="0"/>
                 <a:ea typeface="Calibri" pitchFamily="34" charset="-122"/>
                 <a:cs typeface="Calibri" pitchFamily="34" charset="-120"/>
               </a:rPr>
-              <a:t>Knowledge base loads all 35 entries correctly</a:t>
-            </a:r>
-            <a:endParaRPr lang="en-US" sz="1300" dirty="0"/>
-          </a:p>
-          <a:p>
-            <a:pPr marL="342900" indent="-342900">
-              <a:lnSpc>
-                <a:spcPct val="135000"/>
-              </a:lnSpc>
-              <a:spcAft>
-                <a:spcPts val="1000"/>
-              </a:spcAft>
-              <a:buSzPct val="100000"/>
-              <a:buChar char="✓"/>
-            </a:pPr>
-            <a:r>
-              <a:rPr lang="en-US" sz="1300" dirty="0">
-                <a:solidFill>
-                  <a:srgbClr val="E4ECF7"/>
+              <a:t>BCSE497J · Project I · Review 3</a:t>
+            </a:r>
+            <a:endParaRPr lang="en-US" sz="900" dirty="0"/>
+          </a:p>
+        </p:txBody>
+      </p:sp>
+      <p:sp>
+        <p:nvSpPr>
+          <p:cNvPr id="10" name="Text 8"/>
+          <p:cNvSpPr/>
+          <p:nvPr/>
+        </p:nvSpPr>
+        <p:spPr>
+          <a:xfrm>
+            <a:off x="11274552" y="6492240"/>
+            <a:ext cx="457200" cy="274320"/>
+          </a:xfrm>
+          <a:prstGeom prst="rect">
+            <a:avLst/>
+          </a:prstGeom>
+          <a:noFill/>
+          <a:ln/>
+        </p:spPr>
+        <p:txBody>
+          <a:bodyPr wrap="square" rtlCol="0" anchor="ctr"/>
+          <a:lstStyle/>
+          <a:p>
+            <a:pPr algn="r" indent="0" marL="0">
+              <a:buNone/>
+            </a:pPr>
+            <a:r>
+              <a:rPr lang="en-US" sz="900" dirty="0">
+                <a:solidFill>
+                  <a:srgbClr val="B9C4D6"/>
                 </a:solidFill>
                 <a:latin typeface="Calibri" pitchFamily="34" charset="0"/>
                 <a:ea typeface="Calibri" pitchFamily="34" charset="-122"/>
                 <a:cs typeface="Calibri" pitchFamily="34" charset="-120"/>
               </a:rPr>
-              <a:t>SQL-injection sanity check retrieves CWE-89 at rank 1</a:t>
-            </a:r>
-            <a:endParaRPr lang="en-US" sz="1300" dirty="0"/>
-          </a:p>
-        </p:txBody>
-      </p:sp>
-      <p:sp>
-        <p:nvSpPr>
-          <p:cNvPr id="9" name="Text 7"/>
-          <p:cNvSpPr/>
-          <p:nvPr/>
-        </p:nvSpPr>
-        <p:spPr>
-          <a:xfrm>
-            <a:off x="457200" y="6492240"/>
-            <a:ext cx="5486400" cy="274320"/>
-          </a:xfrm>
-          <a:prstGeom prst="rect">
-            <a:avLst/>
-          </a:prstGeom>
-          <a:noFill/>
-          <a:ln/>
-        </p:spPr>
-        <p:txBody>
-          <a:bodyPr wrap="square" rtlCol="0" anchor="ctr"/>
-          <a:lstStyle/>
-          <a:p>
-            <a:pPr algn="l" indent="0" marL="0">
-              <a:buNone/>
-            </a:pPr>
-            <a:r>
-              <a:rPr lang="en-US" sz="900" dirty="0">
-                <a:solidFill>
-                  <a:srgbClr val="B9C4D6"/>
-                </a:solidFill>
-                <a:latin typeface="Calibri" pitchFamily="34" charset="0"/>
-                <a:ea typeface="Calibri" pitchFamily="34" charset="-122"/>
-                <a:cs typeface="Calibri" pitchFamily="34" charset="-120"/>
-              </a:rPr>
-              <a:t>BCSE497J · Project I · Review 3</a:t>
-            </a:r>
-            <a:endParaRPr lang="en-US" sz="900" dirty="0"/>
-          </a:p>
-        </p:txBody>
-      </p:sp>
-      <p:sp>
-        <p:nvSpPr>
-          <p:cNvPr id="10" name="Text 8"/>
-          <p:cNvSpPr/>
-          <p:nvPr/>
-        </p:nvSpPr>
-        <p:spPr>
-          <a:xfrm>
-            <a:off x="11274552" y="6492240"/>
-            <a:ext cx="457200" cy="274320"/>
-          </a:xfrm>
-          <a:prstGeom prst="rect">
-            <a:avLst/>
-          </a:prstGeom>
-          <a:noFill/>
-          <a:ln/>
-        </p:spPr>
-        <p:txBody>
-          <a:bodyPr wrap="square" rtlCol="0" anchor="ctr"/>
-          <a:lstStyle/>
-          <a:p>
-            <a:pPr algn="r" indent="0" marL="0">
-              <a:buNone/>
-            </a:pPr>
-            <a:r>
-              <a:rPr lang="en-US" sz="900" dirty="0">
-                <a:solidFill>
-                  <a:srgbClr val="B9C4D6"/>
-                </a:solidFill>
-                <a:latin typeface="Calibri" pitchFamily="34" charset="0"/>
-                <a:ea typeface="Calibri" pitchFamily="34" charset="-122"/>
-                <a:cs typeface="Calibri" pitchFamily="34" charset="-120"/>
-              </a:rPr>
-              <a:t>10</a:t>
+              <a:t>11</a:t>
             </a:r>
             <a:endParaRPr lang="en-US" sz="900" dirty="0"/>
           </a:p>
@@ -3091,9 +3665,9 @@
 </p:sld>
 </file>
 
-<file path=ppt/slides/slide11.xml><?xml version="1.0" encoding="utf-8"?>
+<file path=ppt/slides/slide12.xml><?xml version="1.0" encoding="utf-8"?>
 <p:sld xmlns:a="http://schemas.openxmlformats.org/drawingml/2006/main" xmlns:r="http://schemas.openxmlformats.org/officeDocument/2006/relationships" xmlns:p="http://schemas.openxmlformats.org/presentationml/2006/main">
-  <p:cSld name="Slide 11">
+  <p:cSld name="Slide 12">
     <p:bg>
       <p:bgPr>
         <a:solidFill>
@@ -3195,7 +3769,7 @@
       </p:sp>
       <p:graphicFrame>
         <p:nvGraphicFramePr>
-          <p:cNvPr id="12" name="Table 0"/>
+          <p:cNvPr id="13" name="Table 0"/>
           <p:cNvGraphicFramePr>
             <a:graphicFrameLocks noGrp="1"/>
           </p:cNvGraphicFramePr>
@@ -3229,7 +3803,7 @@
                         <a:buNone/>
                       </a:pPr>
                       <a:r>
-                        <a:rPr lang="en-US" sz="1150" b="1" dirty="0">
+                        <a:rPr lang="en-US" sz="1100" b="1" dirty="0">
                           <a:solidFill>
                             <a:srgbClr val="FFFFFF"/>
                           </a:solidFill>
@@ -3239,7 +3813,7 @@
                         </a:rPr>
                         <a:t>Limitation (today)</a:t>
                       </a:r>
-                      <a:endParaRPr lang="en-US" sz="1150" dirty="0">
+                      <a:endParaRPr lang="en-US" sz="1100" dirty="0">
                         <a:latin typeface="Calibri" charset="0"/>
                         <a:ea typeface="Calibri" charset="0"/>
                         <a:cs typeface="Calibri" charset="0"/>
@@ -3297,7 +3871,7 @@
                         <a:buNone/>
                       </a:pPr>
                       <a:r>
-                        <a:rPr lang="en-US" sz="1150" b="1" dirty="0">
+                        <a:rPr lang="en-US" sz="1100" b="1" dirty="0">
                           <a:solidFill>
                             <a:srgbClr val="FFFFFF"/>
                           </a:solidFill>
@@ -3307,7 +3881,7 @@
                         </a:rPr>
                         <a:t>Planned Review 4 Action</a:t>
                       </a:r>
-                      <a:endParaRPr lang="en-US" sz="1150" dirty="0">
+                      <a:endParaRPr lang="en-US" sz="1100" dirty="0">
                         <a:latin typeface="Calibri" charset="0"/>
                         <a:ea typeface="Calibri" charset="0"/>
                         <a:cs typeface="Calibri" charset="0"/>
@@ -3367,7 +3941,7 @@
                         <a:buNone/>
                       </a:pPr>
                       <a:r>
-                        <a:rPr lang="en-US" sz="1150" dirty="0">
+                        <a:rPr lang="en-US" sz="1100" dirty="0">
                           <a:solidFill>
                             <a:srgbClr val="333F4E"/>
                           </a:solidFill>
@@ -3377,7 +3951,7 @@
                         </a:rPr>
                         <a:t>GloVe embedding is a documented substitute for a code-specialised transformer</a:t>
                       </a:r>
-                      <a:endParaRPr lang="en-US" sz="1150" dirty="0">
+                      <a:endParaRPr lang="en-US" sz="1100" dirty="0">
                         <a:latin typeface="Calibri" charset="0"/>
                         <a:ea typeface="Calibri" charset="0"/>
                         <a:cs typeface="Calibri" charset="0"/>
@@ -3432,7 +4006,7 @@
                         <a:buNone/>
                       </a:pPr>
                       <a:r>
-                        <a:rPr lang="en-US" sz="1150" dirty="0">
+                        <a:rPr lang="en-US" sz="1100" dirty="0">
                           <a:solidFill>
                             <a:srgbClr val="333F4E"/>
                           </a:solidFill>
@@ -3442,7 +4016,7 @@
                         </a:rPr>
                         <a:t>Swap in once model hosting/API access is available; re-run the same benchmark to measure the gain</a:t>
                       </a:r>
-                      <a:endParaRPr lang="en-US" sz="1150" dirty="0">
+                      <a:endParaRPr lang="en-US" sz="1100" dirty="0">
                         <a:latin typeface="Calibri" charset="0"/>
                         <a:ea typeface="Calibri" charset="0"/>
                         <a:cs typeface="Calibri" charset="0"/>
@@ -3499,7 +4073,7 @@
                         <a:buNone/>
                       </a:pPr>
                       <a:r>
-                        <a:rPr lang="en-US" sz="1150" dirty="0">
+                        <a:rPr lang="en-US" sz="1100" dirty="0">
                           <a:solidFill>
                             <a:srgbClr val="333F4E"/>
                           </a:solidFill>
@@ -3507,9 +4081,9 @@
                           <a:ea typeface="Calibri" pitchFamily="34" charset="-122"/>
                           <a:cs typeface="Calibri" pitchFamily="34" charset="-120"/>
                         </a:rPr>
-                        <a:t>module.exports = function(){...} wrapper chunks as one large unit</a:t>
+                        <a:t>Access-control CWE family is hard to separate by retrieval alone, and drives most low-confidence severity flags</a:t>
                       </a:r>
-                      <a:endParaRPr lang="en-US" sz="1150" dirty="0">
+                      <a:endParaRPr lang="en-US" sz="1100" dirty="0">
                         <a:latin typeface="Calibri" charset="0"/>
                         <a:ea typeface="Calibri" charset="0"/>
                         <a:cs typeface="Calibri" charset="0"/>
@@ -3564,7 +4138,7 @@
                         <a:buNone/>
                       </a:pPr>
                       <a:r>
-                        <a:rPr lang="en-US" sz="1150" dirty="0">
+                        <a:rPr lang="en-US" sz="1100" dirty="0">
                           <a:solidFill>
                             <a:srgbClr val="333F4E"/>
                           </a:solidFill>
@@ -3572,9 +4146,9 @@
                           <a:ea typeface="Calibri" pitchFamily="34" charset="-122"/>
                           <a:cs typeface="Calibri" pitchFamily="34" charset="-120"/>
                         </a:rPr>
-                        <a:t>Split on inner method definitions for older CommonJS-style code</a:t>
+                        <a:t>Add the LLM reasoning step specifically for this weakness family</a:t>
                       </a:r>
-                      <a:endParaRPr lang="en-US" sz="1150" dirty="0">
+                      <a:endParaRPr lang="en-US" sz="1100" dirty="0">
                         <a:latin typeface="Calibri" charset="0"/>
                         <a:ea typeface="Calibri" charset="0"/>
                         <a:cs typeface="Calibri" charset="0"/>
@@ -3631,7 +4205,7 @@
                         <a:buNone/>
                       </a:pPr>
                       <a:r>
-                        <a:rPr lang="en-US" sz="1150" dirty="0">
+                        <a:rPr lang="en-US" sz="1100" dirty="0">
                           <a:solidFill>
                             <a:srgbClr val="333F4E"/>
                           </a:solidFill>
@@ -3639,9 +4213,9 @@
                           <a:ea typeface="Calibri" pitchFamily="34" charset="-122"/>
                           <a:cs typeface="Calibri" pitchFamily="34" charset="-120"/>
                         </a:rPr>
-                        <a:t>Access-control CWE family (Authorization/IDOR/Access-Control) is hard to separate by retrieval alone</a:t>
+                        <a:t>Remediation templates cover 7 of 25 CWE categories</a:t>
                       </a:r>
-                      <a:endParaRPr lang="en-US" sz="1150" dirty="0">
+                      <a:endParaRPr lang="en-US" sz="1100" dirty="0">
                         <a:latin typeface="Calibri" charset="0"/>
                         <a:ea typeface="Calibri" charset="0"/>
                         <a:cs typeface="Calibri" charset="0"/>
@@ -3696,7 +4270,7 @@
                         <a:buNone/>
                       </a:pPr>
                       <a:r>
-                        <a:rPr lang="en-US" sz="1150" dirty="0">
+                        <a:rPr lang="en-US" sz="1100" dirty="0">
                           <a:solidFill>
                             <a:srgbClr val="333F4E"/>
                           </a:solidFill>
@@ -3704,9 +4278,9 @@
                           <a:ea typeface="Calibri" pitchFamily="34" charset="-122"/>
                           <a:cs typeface="Calibri" pitchFamily="34" charset="-120"/>
                         </a:rPr>
-                        <a:t>Add the LLM reasoning step specifically for this weakness family</a:t>
+                        <a:t>Remaining categories mostly need LLM reasoning, not more templates</a:t>
                       </a:r>
-                      <a:endParaRPr lang="en-US" sz="1150" dirty="0">
+                      <a:endParaRPr lang="en-US" sz="1100" dirty="0">
                         <a:latin typeface="Calibri" charset="0"/>
                         <a:ea typeface="Calibri" charset="0"/>
                         <a:cs typeface="Calibri" charset="0"/>
@@ -3763,7 +4337,7 @@
                         <a:buNone/>
                       </a:pPr>
                       <a:r>
-                        <a:rPr lang="en-US" sz="1150" dirty="0">
+                        <a:rPr lang="en-US" sz="1100" dirty="0">
                           <a:solidFill>
                             <a:srgbClr val="333F4E"/>
                           </a:solidFill>
@@ -3771,9 +4345,9 @@
                           <a:ea typeface="Calibri" pitchFamily="34" charset="-122"/>
                           <a:cs typeface="Calibri" pitchFamily="34" charset="-120"/>
                         </a:rPr>
-                        <a:t>Only Python/JS/TS processed; other languages retained, not analysed</a:t>
+                        <a:t>All findings are candidates (nearest KB match), not yet LLM-confirmed vulnerabilities</a:t>
                       </a:r>
-                      <a:endParaRPr lang="en-US" sz="1150" dirty="0">
+                      <a:endParaRPr lang="en-US" sz="1100" dirty="0">
                         <a:latin typeface="Calibri" charset="0"/>
                         <a:ea typeface="Calibri" charset="0"/>
                         <a:cs typeface="Calibri" charset="0"/>
@@ -3828,7 +4402,7 @@
                         <a:buNone/>
                       </a:pPr>
                       <a:r>
-                        <a:rPr lang="en-US" sz="1150" dirty="0">
+                        <a:rPr lang="en-US" sz="1100" dirty="0">
                           <a:solidFill>
                             <a:srgbClr val="333F4E"/>
                           </a:solidFill>
@@ -3836,9 +4410,9 @@
                           <a:ea typeface="Calibri" pitchFamily="34" charset="-122"/>
                           <a:cs typeface="Calibri" pitchFamily="34" charset="-120"/>
                         </a:rPr>
-                        <a:t>Extend chunking/embedding to further languages per §3.8 future scope</a:t>
+                        <a:t>Build LLM Security Analysis as the confirmation step — top Review 4 priority</a:t>
                       </a:r>
-                      <a:endParaRPr lang="en-US" sz="1150" dirty="0">
+                      <a:endParaRPr lang="en-US" sz="1100" dirty="0">
                         <a:latin typeface="Calibri" charset="0"/>
                         <a:ea typeface="Calibri" charset="0"/>
                         <a:cs typeface="Calibri" charset="0"/>
@@ -3922,7 +4496,7 @@
                 <a:ea typeface="Calibri" pitchFamily="34" charset="-122"/>
                 <a:cs typeface="Calibri" pitchFamily="34" charset="-120"/>
               </a:rPr>
-              <a:t>Review 4 (12–16 Oct 2026): integrate LLM security analysis + rule-based severity scoring end-to-end; initial dashboard.</a:t>
+              <a:t>Review 4 (12–16 Oct 2026): LLM Security Analysis (top priority) → embedding-model swap → minimal dashboard over the Findings Store.</a:t>
             </a:r>
             <a:endParaRPr lang="en-US" sz="1100" dirty="0"/>
           </a:p>
@@ -4000,7 +4574,7 @@
                 <a:ea typeface="Calibri" pitchFamily="34" charset="-122"/>
                 <a:cs typeface="Calibri" pitchFamily="34" charset="-120"/>
               </a:rPr>
-              <a:t>11</a:t>
+              <a:t>12</a:t>
             </a:r>
             <a:endParaRPr lang="en-US" sz="900" dirty="0"/>
           </a:p>
@@ -4014,9 +4588,9 @@
 </p:sld>
 </file>
 
-<file path=ppt/slides/slide12.xml><?xml version="1.0" encoding="utf-8"?>
+<file path=ppt/slides/slide13.xml><?xml version="1.0" encoding="utf-8"?>
 <p:sld xmlns:a="http://schemas.openxmlformats.org/drawingml/2006/main" xmlns:r="http://schemas.openxmlformats.org/officeDocument/2006/relationships" xmlns:p="http://schemas.openxmlformats.org/presentationml/2006/main">
-  <p:cSld name="Slide 12">
+  <p:cSld name="Slide 13">
     <p:bg>
       <p:bgPr>
         <a:solidFill>
@@ -4173,7 +4747,7 @@
                 <a:ea typeface="Calibri" pitchFamily="34" charset="-122"/>
                 <a:cs typeface="Calibri" pitchFamily="34" charset="-120"/>
               </a:rPr>
-              <a:t>5 of 10 modules implemented · 63.6% / 72.7% retrieval accuracy · 7 / 7 tests passing</a:t>
+              <a:t>8 of 10 modules implemented · 63.6% / 72.7% retrieval accuracy · 32 / 32 tests passing</a:t>
             </a:r>
             <a:endParaRPr lang="en-US" sz="1250" dirty="0"/>
           </a:p>
@@ -5676,7 +6250,7 @@
                 <a:ea typeface="Cambria" pitchFamily="34" charset="-122"/>
                 <a:cs typeface="Cambria" pitchFamily="34" charset="-120"/>
               </a:rPr>
-              <a:t>5 of 10 Modules — Implemented and Running</a:t>
+              <a:t>8 of 10 Modules — Implemented and Running</a:t>
             </a:r>
             <a:endParaRPr lang="en-US" sz="2800" dirty="0"/>
           </a:p>
@@ -6918,7 +7492,7 @@
                           <a:ea typeface="Calibri" pitchFamily="34" charset="-122"/>
                           <a:cs typeface="Calibri" pitchFamily="34" charset="-120"/>
                         </a:rPr>
-                        <a:t>LLM Security Analysis</a:t>
+                        <a:t>Severity Scoring</a:t>
                       </a:r>
                       <a:endParaRPr lang="en-US" sz="1030" dirty="0">
                         <a:latin typeface="Calibri" charset="0"/>
@@ -6977,13 +7551,13 @@
                       <a:r>
                         <a:rPr lang="en-US" sz="1030" b="1" dirty="0">
                           <a:solidFill>
-                            <a:srgbClr val="C97A2B"/>
+                            <a:srgbClr val="2E8B57"/>
                           </a:solidFill>
                           <a:latin typeface="Calibri" pitchFamily="34" charset="0"/>
                           <a:ea typeface="Calibri" pitchFamily="34" charset="-122"/>
                           <a:cs typeface="Calibri" pitchFamily="34" charset="-120"/>
                         </a:rPr>
-                        <a:t>Review 4</a:t>
+                        <a:t>✓ Done</a:t>
                       </a:r>
                       <a:endParaRPr lang="en-US" sz="1030" dirty="0">
                         <a:latin typeface="Calibri" charset="0"/>
@@ -7042,13 +7616,13 @@
                       <a:r>
                         <a:rPr lang="en-US" sz="1030" dirty="0">
                           <a:solidFill>
-                            <a:srgbClr val="5B6472"/>
+                            <a:srgbClr val="333F4E"/>
                           </a:solidFill>
                           <a:latin typeface="Calibri" pitchFamily="34" charset="0"/>
                           <a:ea typeface="Calibri" pitchFamily="34" charset="-122"/>
                           <a:cs typeface="Calibri" pitchFamily="34" charset="-120"/>
                         </a:rPr>
-                        <a:t>Requires LLM API provisioning — planned next</a:t>
+                        <a:t>Rule-based/CVSS-inspired, margin-calibrated confidence (§4.8)</a:t>
                       </a:r>
                       <a:endParaRPr lang="en-US" sz="1030" dirty="0">
                         <a:latin typeface="Calibri" charset="0"/>
@@ -7115,7 +7689,7 @@
                           <a:ea typeface="Calibri" pitchFamily="34" charset="-122"/>
                           <a:cs typeface="Calibri" pitchFamily="34" charset="-120"/>
                         </a:rPr>
-                        <a:t>Severity Scoring</a:t>
+                        <a:t>Findings Store</a:t>
                       </a:r>
                       <a:endParaRPr lang="en-US" sz="1030" dirty="0">
                         <a:latin typeface="Calibri" charset="0"/>
@@ -7174,13 +7748,13 @@
                       <a:r>
                         <a:rPr lang="en-US" sz="1030" b="1" dirty="0">
                           <a:solidFill>
-                            <a:srgbClr val="C97A2B"/>
+                            <a:srgbClr val="2E8B57"/>
                           </a:solidFill>
                           <a:latin typeface="Calibri" pitchFamily="34" charset="0"/>
                           <a:ea typeface="Calibri" pitchFamily="34" charset="-122"/>
                           <a:cs typeface="Calibri" pitchFamily="34" charset="-120"/>
                         </a:rPr>
-                        <a:t>Review 4</a:t>
+                        <a:t>✓ Done</a:t>
                       </a:r>
                       <a:endParaRPr lang="en-US" sz="1030" dirty="0">
                         <a:latin typeface="Calibri" charset="0"/>
@@ -7239,13 +7813,13 @@
                       <a:r>
                         <a:rPr lang="en-US" sz="1030" dirty="0">
                           <a:solidFill>
-                            <a:srgbClr val="5B6472"/>
+                            <a:srgbClr val="333F4E"/>
                           </a:solidFill>
                           <a:latin typeface="Calibri" pitchFamily="34" charset="0"/>
                           <a:ea typeface="Calibri" pitchFamily="34" charset="-122"/>
                           <a:cs typeface="Calibri" pitchFamily="34" charset="-120"/>
                         </a:rPr>
-                        <a:t>Rule-based module — designed, not yet coded</a:t>
+                        <a:t>SQLite — documented substitute for MongoDB (§4.8)</a:t>
                       </a:r>
                       <a:endParaRPr lang="en-US" sz="1030" dirty="0">
                         <a:latin typeface="Calibri" charset="0"/>
@@ -7371,13 +7945,13 @@
                       <a:r>
                         <a:rPr lang="en-US" sz="1030" b="1" dirty="0">
                           <a:solidFill>
-                            <a:srgbClr val="5B6472"/>
+                            <a:srgbClr val="2E8B57"/>
                           </a:solidFill>
                           <a:latin typeface="Calibri" pitchFamily="34" charset="0"/>
                           <a:ea typeface="Calibri" pitchFamily="34" charset="-122"/>
                           <a:cs typeface="Calibri" pitchFamily="34" charset="-120"/>
                         </a:rPr>
-                        <a:t>Review 5</a:t>
+                        <a:t>✓ Done</a:t>
                       </a:r>
                       <a:endParaRPr lang="en-US" sz="1030" dirty="0">
                         <a:latin typeface="Calibri" charset="0"/>
@@ -7436,13 +8010,13 @@
                       <a:r>
                         <a:rPr lang="en-US" sz="1030" dirty="0">
                           <a:solidFill>
-                            <a:srgbClr val="5B6472"/>
+                            <a:srgbClr val="333F4E"/>
                           </a:solidFill>
                           <a:latin typeface="Calibri" pitchFamily="34" charset="0"/>
                           <a:ea typeface="Calibri" pitchFamily="34" charset="-122"/>
                           <a:cs typeface="Calibri" pitchFamily="34" charset="-120"/>
                         </a:rPr>
-                        <a:t>Depends on LLM analysis stage</a:t>
+                        <a:t>Template-based, CWE-keyed, 7/25 categories (§4.8)</a:t>
                       </a:r>
                       <a:endParaRPr lang="en-US" sz="1030" dirty="0">
                         <a:latin typeface="Calibri" charset="0"/>
@@ -7509,7 +8083,7 @@
                           <a:ea typeface="Calibri" pitchFamily="34" charset="-122"/>
                           <a:cs typeface="Calibri" pitchFamily="34" charset="-120"/>
                         </a:rPr>
-                        <a:t>Findings Store (MongoDB)</a:t>
+                        <a:t>LLM Security Analysis</a:t>
                       </a:r>
                       <a:endParaRPr lang="en-US" sz="1030" dirty="0">
                         <a:latin typeface="Calibri" charset="0"/>
@@ -7639,7 +8213,7 @@
                           <a:ea typeface="Calibri" pitchFamily="34" charset="-122"/>
                           <a:cs typeface="Calibri" pitchFamily="34" charset="-120"/>
                         </a:rPr>
-                        <a:t>Persistence layer for findings</a:t>
+                        <a:t>Requires LLM API provisioning — planned next</a:t>
                       </a:r>
                       <a:endParaRPr lang="en-US" sz="1030" dirty="0">
                         <a:latin typeface="Calibri" charset="0"/>
@@ -10724,7 +11298,7 @@
                 <a:ea typeface="Calibri" pitchFamily="34" charset="-122"/>
                 <a:cs typeface="Calibri" pitchFamily="34" charset="-120"/>
               </a:rPr>
-              <a:t>5 · RESULTS SO FAR</a:t>
+              <a:t>3 · IMPLEMENTATION</a:t>
             </a:r>
             <a:endParaRPr lang="en-US" sz="1200" dirty="0"/>
           </a:p>
@@ -10763,7 +11337,7 @@
                 <a:ea typeface="Cambria" pitchFamily="34" charset="-122"/>
                 <a:cs typeface="Cambria" pitchFamily="34" charset="-120"/>
               </a:rPr>
-              <a:t>Real-Repository Run: OWASP/NodeGoat</a:t>
+              <a:t>Extending the Pipeline: Severity, Storage, Remediation</a:t>
             </a:r>
             <a:endParaRPr lang="en-US" sz="2800" dirty="0"/>
           </a:p>
@@ -10771,46 +11345,29 @@
       </p:sp>
       <p:sp>
         <p:nvSpPr>
-          <p:cNvPr id="4" name="Text 2"/>
-          <p:cNvSpPr/>
-          <p:nvPr/>
-        </p:nvSpPr>
-        <p:spPr>
-          <a:xfrm>
-            <a:off x="548640" y="1508760"/>
-            <a:ext cx="11064240" cy="411480"/>
-          </a:xfrm>
-          <a:prstGeom prst="rect">
-            <a:avLst/>
-          </a:prstGeom>
-          <a:noFill/>
-          <a:ln/>
-        </p:spPr>
-        <p:txBody>
-          <a:bodyPr wrap="square" rtlCol="0" anchor="ctr"/>
-          <a:lstStyle/>
-          <a:p>
-            <a:pPr indent="0" marL="0">
-              <a:buNone/>
-            </a:pPr>
-            <a:r>
-              <a:rPr lang="en-US" sz="1200" i="1" dirty="0">
-                <a:solidFill>
-                  <a:srgbClr val="5B6472"/>
-                </a:solidFill>
-                <a:latin typeface="Calibri" pitchFamily="34" charset="0"/>
-                <a:ea typeface="Calibri" pitchFamily="34" charset="-122"/>
-                <a:cs typeface="Calibri" pitchFamily="34" charset="-120"/>
-              </a:rPr>
-              <a:t>A public, intentionally-vulnerable Node.js reference application — small enough to inspect by hand, well known enough for an external sanity check.</a:t>
-            </a:r>
-            <a:endParaRPr lang="en-US" sz="1200" dirty="0"/>
-          </a:p>
-        </p:txBody>
+          <p:cNvPr id="4" name="Shape 2"/>
+          <p:cNvSpPr/>
+          <p:nvPr/>
+        </p:nvSpPr>
+        <p:spPr>
+          <a:xfrm>
+            <a:off x="548640" y="1554480"/>
+            <a:ext cx="3520440" cy="2331720"/>
+          </a:xfrm>
+          <a:prstGeom prst="roundRect">
+            <a:avLst>
+              <a:gd name="adj" fmla="val 3922"/>
+            </a:avLst>
+          </a:prstGeom>
+          <a:solidFill>
+            <a:srgbClr val="065A82"/>
+          </a:solidFill>
+          <a:ln/>
+        </p:spPr>
       </p:sp>
       <p:pic>
         <p:nvPicPr>
-          <p:cNvPr id="5" name="Image 0" descr="../results/ingestion_funnel.png">    </p:cNvPr>
+          <p:cNvPr id="5" name="Image 0" descr="icon_FaExclamationTriangle.png">    </p:cNvPr>
           <p:cNvPicPr>
             <a:picLocks noChangeAspect="1"/>
           </p:cNvPicPr>
@@ -10824,17 +11381,195 @@
         </p:blipFill>
         <p:spPr>
           <a:xfrm>
-            <a:off x="457200" y="1965960"/>
-            <a:ext cx="5577840" cy="4206240"/>
+            <a:off x="2071116" y="1755648"/>
+            <a:ext cx="475488" cy="475488"/>
           </a:xfrm>
           <a:prstGeom prst="rect">
             <a:avLst/>
           </a:prstGeom>
         </p:spPr>
       </p:pic>
+      <p:sp>
+        <p:nvSpPr>
+          <p:cNvPr id="6" name="Text 3"/>
+          <p:cNvSpPr/>
+          <p:nvPr/>
+        </p:nvSpPr>
+        <p:spPr>
+          <a:xfrm>
+            <a:off x="685800" y="2267712"/>
+            <a:ext cx="3246120" cy="320040"/>
+          </a:xfrm>
+          <a:prstGeom prst="rect">
+            <a:avLst/>
+          </a:prstGeom>
+          <a:noFill/>
+          <a:ln/>
+        </p:spPr>
+        <p:txBody>
+          <a:bodyPr wrap="square" rtlCol="0" anchor="ctr"/>
+          <a:lstStyle/>
+          <a:p>
+            <a:pPr algn="ctr" indent="0" marL="0">
+              <a:buNone/>
+            </a:pPr>
+            <a:r>
+              <a:rPr lang="en-US" sz="1200" b="1" dirty="0">
+                <a:solidFill>
+                  <a:srgbClr val="8FD3E8"/>
+                </a:solidFill>
+                <a:latin typeface="Cambria" pitchFamily="34" charset="0"/>
+                <a:ea typeface="Cambria" pitchFamily="34" charset="-122"/>
+                <a:cs typeface="Cambria" pitchFamily="34" charset="-120"/>
+              </a:rPr>
+              <a:t>6</a:t>
+            </a:r>
+            <a:endParaRPr lang="en-US" sz="1200" dirty="0"/>
+          </a:p>
+        </p:txBody>
+      </p:sp>
+      <p:sp>
+        <p:nvSpPr>
+          <p:cNvPr id="7" name="Text 4"/>
+          <p:cNvSpPr/>
+          <p:nvPr/>
+        </p:nvSpPr>
+        <p:spPr>
+          <a:xfrm>
+            <a:off x="685800" y="2542032"/>
+            <a:ext cx="3246120" cy="365760"/>
+          </a:xfrm>
+          <a:prstGeom prst="rect">
+            <a:avLst/>
+          </a:prstGeom>
+          <a:noFill/>
+          <a:ln/>
+        </p:spPr>
+        <p:txBody>
+          <a:bodyPr wrap="square" rtlCol="0" anchor="ctr"/>
+          <a:lstStyle/>
+          <a:p>
+            <a:pPr algn="ctr" indent="0" marL="0">
+              <a:buNone/>
+            </a:pPr>
+            <a:r>
+              <a:rPr lang="en-US" sz="1500" b="1" dirty="0">
+                <a:solidFill>
+                  <a:srgbClr val="FFFFFF"/>
+                </a:solidFill>
+                <a:latin typeface="Calibri" pitchFamily="34" charset="0"/>
+                <a:ea typeface="Calibri" pitchFamily="34" charset="-122"/>
+                <a:cs typeface="Calibri" pitchFamily="34" charset="-120"/>
+              </a:rPr>
+              <a:t>Score</a:t>
+            </a:r>
+            <a:endParaRPr lang="en-US" sz="1500" dirty="0"/>
+          </a:p>
+        </p:txBody>
+      </p:sp>
+      <p:sp>
+        <p:nvSpPr>
+          <p:cNvPr id="8" name="Text 5"/>
+          <p:cNvSpPr/>
+          <p:nvPr/>
+        </p:nvSpPr>
+        <p:spPr>
+          <a:xfrm>
+            <a:off x="731520" y="2944368"/>
+            <a:ext cx="3154680" cy="822960"/>
+          </a:xfrm>
+          <a:prstGeom prst="rect">
+            <a:avLst/>
+          </a:prstGeom>
+          <a:noFill/>
+          <a:ln/>
+        </p:spPr>
+        <p:txBody>
+          <a:bodyPr wrap="square" rtlCol="0" anchor="t"/>
+          <a:lstStyle/>
+          <a:p>
+            <a:pPr algn="ctr" indent="0" marL="0">
+              <a:lnSpc>
+                <a:spcPct val="120000"/>
+              </a:lnSpc>
+              <a:buNone/>
+            </a:pPr>
+            <a:r>
+              <a:rPr lang="en-US" sz="960" dirty="0">
+                <a:solidFill>
+                  <a:srgbClr val="DCE8F5"/>
+                </a:solidFill>
+                <a:latin typeface="Calibri" pitchFamily="34" charset="0"/>
+                <a:ea typeface="Calibri" pitchFamily="34" charset="-122"/>
+                <a:cs typeface="Calibri" pitchFamily="34" charset="-120"/>
+              </a:rPr>
+              <a:t>Rule-based/CVSS-inspired band + score, downgraded when retrieval margin is below a calibrated threshold (0.015)</a:t>
+            </a:r>
+            <a:endParaRPr lang="en-US" sz="960" dirty="0"/>
+          </a:p>
+        </p:txBody>
+      </p:sp>
+      <p:sp>
+        <p:nvSpPr>
+          <p:cNvPr id="9" name="Text 6"/>
+          <p:cNvSpPr/>
+          <p:nvPr/>
+        </p:nvSpPr>
+        <p:spPr>
+          <a:xfrm>
+            <a:off x="4069080" y="2519172"/>
+            <a:ext cx="274320" cy="402336"/>
+          </a:xfrm>
+          <a:prstGeom prst="rect">
+            <a:avLst/>
+          </a:prstGeom>
+          <a:noFill/>
+          <a:ln/>
+        </p:spPr>
+        <p:txBody>
+          <a:bodyPr wrap="square" rtlCol="0" anchor="ctr"/>
+          <a:lstStyle/>
+          <a:p>
+            <a:pPr algn="ctr" indent="0" marL="0">
+              <a:buNone/>
+            </a:pPr>
+            <a:r>
+              <a:rPr lang="en-US" sz="1500" b="1" dirty="0">
+                <a:solidFill>
+                  <a:srgbClr val="1C7293"/>
+                </a:solidFill>
+              </a:rPr>
+              <a:t>→</a:t>
+            </a:r>
+            <a:endParaRPr lang="en-US" sz="1500" dirty="0"/>
+          </a:p>
+        </p:txBody>
+      </p:sp>
+      <p:sp>
+        <p:nvSpPr>
+          <p:cNvPr id="10" name="Shape 7"/>
+          <p:cNvSpPr/>
+          <p:nvPr/>
+        </p:nvSpPr>
+        <p:spPr>
+          <a:xfrm>
+            <a:off x="4343400" y="1554480"/>
+            <a:ext cx="3520440" cy="2331720"/>
+          </a:xfrm>
+          <a:prstGeom prst="roundRect">
+            <a:avLst>
+              <a:gd name="adj" fmla="val 3922"/>
+            </a:avLst>
+          </a:prstGeom>
+          <a:solidFill>
+            <a:srgbClr val="065A82"/>
+          </a:solidFill>
+          <a:ln/>
+        </p:spPr>
+      </p:sp>
       <p:pic>
         <p:nvPicPr>
-          <p:cNvPr id="6" name="Image 1" descr="../results/chunking_timing.png">    </p:cNvPr>
+          <p:cNvPr id="11" name="Image 1" descr="icon_FaDatabase.png">    </p:cNvPr>
           <p:cNvPicPr>
             <a:picLocks noChangeAspect="1"/>
           </p:cNvPicPr>
@@ -10848,8 +11583,8 @@
         </p:blipFill>
         <p:spPr>
           <a:xfrm>
-            <a:off x="6172200" y="1965960"/>
-            <a:ext cx="5577840" cy="4206240"/>
+            <a:off x="5865876" y="1755648"/>
+            <a:ext cx="475488" cy="475488"/>
           </a:xfrm>
           <a:prstGeom prst="rect">
             <a:avLst/>
@@ -10858,14 +11593,14 @@
       </p:pic>
       <p:sp>
         <p:nvSpPr>
-          <p:cNvPr id="7" name="Text 3"/>
-          <p:cNvSpPr/>
-          <p:nvPr/>
-        </p:nvSpPr>
-        <p:spPr>
-          <a:xfrm>
-            <a:off x="457200" y="6492240"/>
-            <a:ext cx="5486400" cy="274320"/>
+          <p:cNvPr id="12" name="Text 8"/>
+          <p:cNvSpPr/>
+          <p:nvPr/>
+        </p:nvSpPr>
+        <p:spPr>
+          <a:xfrm>
+            <a:off x="4480560" y="2267712"/>
+            <a:ext cx="3246120" cy="320040"/>
           </a:xfrm>
           <a:prstGeom prst="rect">
             <a:avLst/>
@@ -10877,18 +11612,530 @@
           <a:bodyPr wrap="square" rtlCol="0" anchor="ctr"/>
           <a:lstStyle/>
           <a:p>
-            <a:pPr algn="l" indent="0" marL="0">
-              <a:buNone/>
-            </a:pPr>
-            <a:r>
-              <a:rPr lang="en-US" sz="900" dirty="0">
-                <a:solidFill>
-                  <a:srgbClr val="5B6472"/>
+            <a:pPr algn="ctr" indent="0" marL="0">
+              <a:buNone/>
+            </a:pPr>
+            <a:r>
+              <a:rPr lang="en-US" sz="1200" b="1" dirty="0">
+                <a:solidFill>
+                  <a:srgbClr val="8FD3E8"/>
+                </a:solidFill>
+                <a:latin typeface="Cambria" pitchFamily="34" charset="0"/>
+                <a:ea typeface="Cambria" pitchFamily="34" charset="-122"/>
+                <a:cs typeface="Cambria" pitchFamily="34" charset="-120"/>
+              </a:rPr>
+              <a:t>7</a:t>
+            </a:r>
+            <a:endParaRPr lang="en-US" sz="1200" dirty="0"/>
+          </a:p>
+        </p:txBody>
+      </p:sp>
+      <p:sp>
+        <p:nvSpPr>
+          <p:cNvPr id="13" name="Text 9"/>
+          <p:cNvSpPr/>
+          <p:nvPr/>
+        </p:nvSpPr>
+        <p:spPr>
+          <a:xfrm>
+            <a:off x="4480560" y="2542032"/>
+            <a:ext cx="3246120" cy="365760"/>
+          </a:xfrm>
+          <a:prstGeom prst="rect">
+            <a:avLst/>
+          </a:prstGeom>
+          <a:noFill/>
+          <a:ln/>
+        </p:spPr>
+        <p:txBody>
+          <a:bodyPr wrap="square" rtlCol="0" anchor="ctr"/>
+          <a:lstStyle/>
+          <a:p>
+            <a:pPr algn="ctr" indent="0" marL="0">
+              <a:buNone/>
+            </a:pPr>
+            <a:r>
+              <a:rPr lang="en-US" sz="1500" b="1" dirty="0">
+                <a:solidFill>
+                  <a:srgbClr val="FFFFFF"/>
                 </a:solidFill>
                 <a:latin typeface="Calibri" pitchFamily="34" charset="0"/>
                 <a:ea typeface="Calibri" pitchFamily="34" charset="-122"/>
                 <a:cs typeface="Calibri" pitchFamily="34" charset="-120"/>
               </a:rPr>
+              <a:t>Store</a:t>
+            </a:r>
+            <a:endParaRPr lang="en-US" sz="1500" dirty="0"/>
+          </a:p>
+        </p:txBody>
+      </p:sp>
+      <p:sp>
+        <p:nvSpPr>
+          <p:cNvPr id="14" name="Text 10"/>
+          <p:cNvSpPr/>
+          <p:nvPr/>
+        </p:nvSpPr>
+        <p:spPr>
+          <a:xfrm>
+            <a:off x="4526280" y="2944368"/>
+            <a:ext cx="3154680" cy="822960"/>
+          </a:xfrm>
+          <a:prstGeom prst="rect">
+            <a:avLst/>
+          </a:prstGeom>
+          <a:noFill/>
+          <a:ln/>
+        </p:spPr>
+        <p:txBody>
+          <a:bodyPr wrap="square" rtlCol="0" anchor="t"/>
+          <a:lstStyle/>
+          <a:p>
+            <a:pPr algn="ctr" indent="0" marL="0">
+              <a:lnSpc>
+                <a:spcPct val="120000"/>
+              </a:lnSpc>
+              <a:buNone/>
+            </a:pPr>
+            <a:r>
+              <a:rPr lang="en-US" sz="960" dirty="0">
+                <a:solidFill>
+                  <a:srgbClr val="DCE8F5"/>
+                </a:solidFill>
+                <a:latin typeface="Calibri" pitchFamily="34" charset="0"/>
+                <a:ea typeface="Calibri" pitchFamily="34" charset="-122"/>
+                <a:cs typeface="Calibri" pitchFamily="34" charset="-120"/>
+              </a:rPr>
+              <a:t>SQLite findings store (documented substitute for MongoDB — no server package installable in the build sandbox)</a:t>
+            </a:r>
+            <a:endParaRPr lang="en-US" sz="960" dirty="0"/>
+          </a:p>
+        </p:txBody>
+      </p:sp>
+      <p:sp>
+        <p:nvSpPr>
+          <p:cNvPr id="15" name="Text 11"/>
+          <p:cNvSpPr/>
+          <p:nvPr/>
+        </p:nvSpPr>
+        <p:spPr>
+          <a:xfrm>
+            <a:off x="7863840" y="2519172"/>
+            <a:ext cx="274320" cy="402336"/>
+          </a:xfrm>
+          <a:prstGeom prst="rect">
+            <a:avLst/>
+          </a:prstGeom>
+          <a:noFill/>
+          <a:ln/>
+        </p:spPr>
+        <p:txBody>
+          <a:bodyPr wrap="square" rtlCol="0" anchor="ctr"/>
+          <a:lstStyle/>
+          <a:p>
+            <a:pPr algn="ctr" indent="0" marL="0">
+              <a:buNone/>
+            </a:pPr>
+            <a:r>
+              <a:rPr lang="en-US" sz="1500" b="1" dirty="0">
+                <a:solidFill>
+                  <a:srgbClr val="1C7293"/>
+                </a:solidFill>
+              </a:rPr>
+              <a:t>→</a:t>
+            </a:r>
+            <a:endParaRPr lang="en-US" sz="1500" dirty="0"/>
+          </a:p>
+        </p:txBody>
+      </p:sp>
+      <p:sp>
+        <p:nvSpPr>
+          <p:cNvPr id="16" name="Shape 12"/>
+          <p:cNvSpPr/>
+          <p:nvPr/>
+        </p:nvSpPr>
+        <p:spPr>
+          <a:xfrm>
+            <a:off x="8138160" y="1554480"/>
+            <a:ext cx="3520440" cy="2331720"/>
+          </a:xfrm>
+          <a:prstGeom prst="roundRect">
+            <a:avLst>
+              <a:gd name="adj" fmla="val 3922"/>
+            </a:avLst>
+          </a:prstGeom>
+          <a:solidFill>
+            <a:srgbClr val="065A82"/>
+          </a:solidFill>
+          <a:ln/>
+        </p:spPr>
+      </p:sp>
+      <p:pic>
+        <p:nvPicPr>
+          <p:cNvPr id="17" name="Image 2" descr="icon_FaCheckCircle.png">    </p:cNvPr>
+          <p:cNvPicPr>
+            <a:picLocks noChangeAspect="1"/>
+          </p:cNvPicPr>
+          <p:nvPr/>
+        </p:nvPicPr>
+        <p:blipFill>
+          <a:blip r:embed="rId3"/>
+          <a:stretch>
+            <a:fillRect/>
+          </a:stretch>
+        </p:blipFill>
+        <p:spPr>
+          <a:xfrm>
+            <a:off x="9660636" y="1755648"/>
+            <a:ext cx="475488" cy="475488"/>
+          </a:xfrm>
+          <a:prstGeom prst="rect">
+            <a:avLst/>
+          </a:prstGeom>
+        </p:spPr>
+      </p:pic>
+      <p:sp>
+        <p:nvSpPr>
+          <p:cNvPr id="18" name="Text 13"/>
+          <p:cNvSpPr/>
+          <p:nvPr/>
+        </p:nvSpPr>
+        <p:spPr>
+          <a:xfrm>
+            <a:off x="8275320" y="2267712"/>
+            <a:ext cx="3246120" cy="320040"/>
+          </a:xfrm>
+          <a:prstGeom prst="rect">
+            <a:avLst/>
+          </a:prstGeom>
+          <a:noFill/>
+          <a:ln/>
+        </p:spPr>
+        <p:txBody>
+          <a:bodyPr wrap="square" rtlCol="0" anchor="ctr"/>
+          <a:lstStyle/>
+          <a:p>
+            <a:pPr algn="ctr" indent="0" marL="0">
+              <a:buNone/>
+            </a:pPr>
+            <a:r>
+              <a:rPr lang="en-US" sz="1200" b="1" dirty="0">
+                <a:solidFill>
+                  <a:srgbClr val="8FD3E8"/>
+                </a:solidFill>
+                <a:latin typeface="Cambria" pitchFamily="34" charset="0"/>
+                <a:ea typeface="Cambria" pitchFamily="34" charset="-122"/>
+                <a:cs typeface="Cambria" pitchFamily="34" charset="-120"/>
+              </a:rPr>
+              <a:t>8</a:t>
+            </a:r>
+            <a:endParaRPr lang="en-US" sz="1200" dirty="0"/>
+          </a:p>
+        </p:txBody>
+      </p:sp>
+      <p:sp>
+        <p:nvSpPr>
+          <p:cNvPr id="19" name="Text 14"/>
+          <p:cNvSpPr/>
+          <p:nvPr/>
+        </p:nvSpPr>
+        <p:spPr>
+          <a:xfrm>
+            <a:off x="8275320" y="2542032"/>
+            <a:ext cx="3246120" cy="365760"/>
+          </a:xfrm>
+          <a:prstGeom prst="rect">
+            <a:avLst/>
+          </a:prstGeom>
+          <a:noFill/>
+          <a:ln/>
+        </p:spPr>
+        <p:txBody>
+          <a:bodyPr wrap="square" rtlCol="0" anchor="ctr"/>
+          <a:lstStyle/>
+          <a:p>
+            <a:pPr algn="ctr" indent="0" marL="0">
+              <a:buNone/>
+            </a:pPr>
+            <a:r>
+              <a:rPr lang="en-US" sz="1500" b="1" dirty="0">
+                <a:solidFill>
+                  <a:srgbClr val="FFFFFF"/>
+                </a:solidFill>
+                <a:latin typeface="Calibri" pitchFamily="34" charset="0"/>
+                <a:ea typeface="Calibri" pitchFamily="34" charset="-122"/>
+                <a:cs typeface="Calibri" pitchFamily="34" charset="-120"/>
+              </a:rPr>
+              <a:t>Remediate</a:t>
+            </a:r>
+            <a:endParaRPr lang="en-US" sz="1500" dirty="0"/>
+          </a:p>
+        </p:txBody>
+      </p:sp>
+      <p:sp>
+        <p:nvSpPr>
+          <p:cNvPr id="20" name="Text 15"/>
+          <p:cNvSpPr/>
+          <p:nvPr/>
+        </p:nvSpPr>
+        <p:spPr>
+          <a:xfrm>
+            <a:off x="8321040" y="2944368"/>
+            <a:ext cx="3154680" cy="822960"/>
+          </a:xfrm>
+          <a:prstGeom prst="rect">
+            <a:avLst/>
+          </a:prstGeom>
+          <a:noFill/>
+          <a:ln/>
+        </p:spPr>
+        <p:txBody>
+          <a:bodyPr wrap="square" rtlCol="0" anchor="t"/>
+          <a:lstStyle/>
+          <a:p>
+            <a:pPr algn="ctr" indent="0" marL="0">
+              <a:lnSpc>
+                <a:spcPct val="120000"/>
+              </a:lnSpc>
+              <a:buNone/>
+            </a:pPr>
+            <a:r>
+              <a:rPr lang="en-US" sz="960" dirty="0">
+                <a:solidFill>
+                  <a:srgbClr val="DCE8F5"/>
+                </a:solidFill>
+                <a:latin typeface="Calibri" pitchFamily="34" charset="0"/>
+                <a:ea typeface="Calibri" pitchFamily="34" charset="-122"/>
+                <a:cs typeface="Calibri" pitchFamily="34" charset="-120"/>
+              </a:rPr>
+              <a:t>Template-based, CWE-keyed before/after fix — 7 of 25 categories covered; developer-reviewed, never auto-applied</a:t>
+            </a:r>
+            <a:endParaRPr lang="en-US" sz="960" dirty="0"/>
+          </a:p>
+        </p:txBody>
+      </p:sp>
+      <p:sp>
+        <p:nvSpPr>
+          <p:cNvPr id="21" name="Text 16"/>
+          <p:cNvSpPr/>
+          <p:nvPr/>
+        </p:nvSpPr>
+        <p:spPr>
+          <a:xfrm>
+            <a:off x="548640" y="4114800"/>
+            <a:ext cx="11064240" cy="320040"/>
+          </a:xfrm>
+          <a:prstGeom prst="rect">
+            <a:avLst/>
+          </a:prstGeom>
+          <a:noFill/>
+          <a:ln/>
+        </p:spPr>
+        <p:txBody>
+          <a:bodyPr wrap="square" rtlCol="0" anchor="ctr"/>
+          <a:lstStyle/>
+          <a:p>
+            <a:pPr indent="0" marL="0">
+              <a:buNone/>
+            </a:pPr>
+            <a:r>
+              <a:rPr lang="en-US" sz="1200" b="1" dirty="0">
+                <a:solidFill>
+                  <a:srgbClr val="21295C"/>
+                </a:solidFill>
+                <a:latin typeface="Calibri" pitchFamily="34" charset="0"/>
+                <a:ea typeface="Calibri" pitchFamily="34" charset="-122"/>
+                <a:cs typeface="Calibri" pitchFamily="34" charset="-120"/>
+              </a:rPr>
+              <a:t>Two of three are honest, documented substitutions — same discipline as the embedding-model decision (slide 6):</a:t>
+            </a:r>
+            <a:endParaRPr lang="en-US" sz="1200" dirty="0"/>
+          </a:p>
+        </p:txBody>
+      </p:sp>
+      <p:sp>
+        <p:nvSpPr>
+          <p:cNvPr id="22" name="Text 17"/>
+          <p:cNvSpPr/>
+          <p:nvPr/>
+        </p:nvSpPr>
+        <p:spPr>
+          <a:xfrm>
+            <a:off x="548640" y="4480560"/>
+            <a:ext cx="11064240" cy="1005840"/>
+          </a:xfrm>
+          <a:prstGeom prst="rect">
+            <a:avLst/>
+          </a:prstGeom>
+          <a:noFill/>
+          <a:ln/>
+        </p:spPr>
+        <p:txBody>
+          <a:bodyPr wrap="square" rtlCol="0" anchor="t"/>
+          <a:lstStyle/>
+          <a:p>
+            <a:pPr marL="342900" indent="-342900">
+              <a:lnSpc>
+                <a:spcPct val="125000"/>
+              </a:lnSpc>
+              <a:spcAft>
+                <a:spcPts val="600"/>
+              </a:spcAft>
+              <a:buSzPct val="100000"/>
+              <a:buChar char="•"/>
+            </a:pPr>
+            <a:r>
+              <a:rPr lang="en-US" sz="1100" dirty="0">
+                <a:solidFill>
+                  <a:srgbClr val="333F4E"/>
+                </a:solidFill>
+                <a:latin typeface="Calibri" pitchFamily="34" charset="0"/>
+                <a:ea typeface="Calibri" pitchFamily="34" charset="-122"/>
+                <a:cs typeface="Calibri" pitchFamily="34" charset="-120"/>
+              </a:rPr>
+              <a:t>Findings Store: MongoDB has no installable server package in this build sandbox → SQLite, document-shaped schema, same functional role.</a:t>
+            </a:r>
+            <a:endParaRPr lang="en-US" sz="1100" dirty="0"/>
+          </a:p>
+          <a:p>
+            <a:pPr marL="342900" indent="-342900">
+              <a:lnSpc>
+                <a:spcPct val="125000"/>
+              </a:lnSpc>
+              <a:spcAft>
+                <a:spcPts val="600"/>
+              </a:spcAft>
+              <a:buSzPct val="100000"/>
+              <a:buChar char="•"/>
+            </a:pPr>
+            <a:r>
+              <a:rPr lang="en-US" sz="1100" dirty="0">
+                <a:solidFill>
+                  <a:srgbClr val="333F4E"/>
+                </a:solidFill>
+                <a:latin typeface="Calibri" pitchFamily="34" charset="0"/>
+                <a:ea typeface="Calibri" pitchFamily="34" charset="-122"/>
+                <a:cs typeface="Calibri" pitchFamily="34" charset="-120"/>
+              </a:rPr>
+              <a:t>Remediation Generation: full LLM-generated fixes need an LLM API this sandbox can't reach this sprint → template-based generator for 7 CWE categories with a mechanical fix pattern; the other 18 explicitly return "no template" rather than a guess.</a:t>
+            </a:r>
+            <a:endParaRPr lang="en-US" sz="1100" dirty="0"/>
+          </a:p>
+        </p:txBody>
+      </p:sp>
+      <p:sp>
+        <p:nvSpPr>
+          <p:cNvPr id="23" name="Shape 18"/>
+          <p:cNvSpPr/>
+          <p:nvPr/>
+        </p:nvSpPr>
+        <p:spPr>
+          <a:xfrm>
+            <a:off x="548640" y="5623560"/>
+            <a:ext cx="11109960" cy="566928"/>
+          </a:xfrm>
+          <a:prstGeom prst="roundRect">
+            <a:avLst>
+              <a:gd name="adj" fmla="val 11290"/>
+            </a:avLst>
+          </a:prstGeom>
+          <a:solidFill>
+            <a:srgbClr val="EAF3F8"/>
+          </a:solidFill>
+          <a:ln/>
+        </p:spPr>
+      </p:sp>
+      <p:sp>
+        <p:nvSpPr>
+          <p:cNvPr id="24" name="Text 19"/>
+          <p:cNvSpPr/>
+          <p:nvPr/>
+        </p:nvSpPr>
+        <p:spPr>
+          <a:xfrm>
+            <a:off x="777240" y="5623560"/>
+            <a:ext cx="10607040" cy="566928"/>
+          </a:xfrm>
+          <a:prstGeom prst="rect">
+            <a:avLst/>
+          </a:prstGeom>
+          <a:noFill/>
+          <a:ln/>
+        </p:spPr>
+        <p:txBody>
+          <a:bodyPr wrap="square" rtlCol="0" anchor="ctr"/>
+          <a:lstStyle/>
+          <a:p>
+            <a:pPr indent="0" marL="0">
+              <a:lnSpc>
+                <a:spcPct val="115000"/>
+              </a:lnSpc>
+              <a:buNone/>
+            </a:pPr>
+            <a:r>
+              <a:rPr lang="en-US" sz="1080" b="1" dirty="0">
+                <a:solidFill>
+                  <a:srgbClr val="1C7293"/>
+                </a:solidFill>
+                <a:latin typeface="Calibri" pitchFamily="34" charset="0"/>
+                <a:ea typeface="Calibri" pitchFamily="34" charset="-122"/>
+                <a:cs typeface="Calibri" pitchFamily="34" charset="-120"/>
+              </a:rPr>
+              <a:t>Candidate findings, not verified vulnerabilities: </a:t>
+            </a:r>
+            <a:pPr indent="0" marL="0">
+              <a:lnSpc>
+                <a:spcPct val="115000"/>
+              </a:lnSpc>
+              <a:buNone/>
+            </a:pPr>
+            <a:r>
+              <a:rPr lang="en-US" sz="1080" dirty="0">
+                <a:solidFill>
+                  <a:srgbClr val="333F4E"/>
+                </a:solidFill>
+                <a:latin typeface="Calibri" pitchFamily="34" charset="0"/>
+                <a:ea typeface="Calibri" pitchFamily="34" charset="-122"/>
+                <a:cs typeface="Calibri" pitchFamily="34" charset="-120"/>
+              </a:rPr>
+              <a:t>every score/store/remediation above treats the nearest KB match as if it were a true positive — confirmation is the LLM Security Analysis module (Review 4).</a:t>
+            </a:r>
+            <a:endParaRPr lang="en-US" sz="1080" dirty="0"/>
+          </a:p>
+        </p:txBody>
+      </p:sp>
+      <p:sp>
+        <p:nvSpPr>
+          <p:cNvPr id="25" name="Text 20"/>
+          <p:cNvSpPr/>
+          <p:nvPr/>
+        </p:nvSpPr>
+        <p:spPr>
+          <a:xfrm>
+            <a:off x="457200" y="6492240"/>
+            <a:ext cx="5486400" cy="274320"/>
+          </a:xfrm>
+          <a:prstGeom prst="rect">
+            <a:avLst/>
+          </a:prstGeom>
+          <a:noFill/>
+          <a:ln/>
+        </p:spPr>
+        <p:txBody>
+          <a:bodyPr wrap="square" rtlCol="0" anchor="ctr"/>
+          <a:lstStyle/>
+          <a:p>
+            <a:pPr algn="l" indent="0" marL="0">
+              <a:buNone/>
+            </a:pPr>
+            <a:r>
+              <a:rPr lang="en-US" sz="900" dirty="0">
+                <a:solidFill>
+                  <a:srgbClr val="5B6472"/>
+                </a:solidFill>
+                <a:latin typeface="Calibri" pitchFamily="34" charset="0"/>
+                <a:ea typeface="Calibri" pitchFamily="34" charset="-122"/>
+                <a:cs typeface="Calibri" pitchFamily="34" charset="-120"/>
+              </a:rPr>
               <a:t>BCSE497J · Project I · Review 3</a:t>
             </a:r>
             <a:endParaRPr lang="en-US" sz="900" dirty="0"/>
@@ -10897,7 +12144,7 @@
       </p:sp>
       <p:sp>
         <p:nvSpPr>
-          <p:cNvPr id="8" name="Text 4"/>
+          <p:cNvPr id="26" name="Text 21"/>
           <p:cNvSpPr/>
           <p:nvPr/>
         </p:nvSpPr>
@@ -11038,15 +12285,54 @@
                 <a:ea typeface="Cambria" pitchFamily="34" charset="-122"/>
                 <a:cs typeface="Cambria" pitchFamily="34" charset="-120"/>
               </a:rPr>
-              <a:t>Retrieval-Accuracy Benchmark (22 Labeled Snippets)</a:t>
+              <a:t>Real-Repository Run: OWASP/NodeGoat</a:t>
             </a:r>
             <a:endParaRPr lang="en-US" sz="2800" dirty="0"/>
+          </a:p>
+        </p:txBody>
+      </p:sp>
+      <p:sp>
+        <p:nvSpPr>
+          <p:cNvPr id="4" name="Text 2"/>
+          <p:cNvSpPr/>
+          <p:nvPr/>
+        </p:nvSpPr>
+        <p:spPr>
+          <a:xfrm>
+            <a:off x="548640" y="1508760"/>
+            <a:ext cx="11064240" cy="411480"/>
+          </a:xfrm>
+          <a:prstGeom prst="rect">
+            <a:avLst/>
+          </a:prstGeom>
+          <a:noFill/>
+          <a:ln/>
+        </p:spPr>
+        <p:txBody>
+          <a:bodyPr wrap="square" rtlCol="0" anchor="ctr"/>
+          <a:lstStyle/>
+          <a:p>
+            <a:pPr indent="0" marL="0">
+              <a:buNone/>
+            </a:pPr>
+            <a:r>
+              <a:rPr lang="en-US" sz="1200" i="1" dirty="0">
+                <a:solidFill>
+                  <a:srgbClr val="5B6472"/>
+                </a:solidFill>
+                <a:latin typeface="Calibri" pitchFamily="34" charset="0"/>
+                <a:ea typeface="Calibri" pitchFamily="34" charset="-122"/>
+                <a:cs typeface="Calibri" pitchFamily="34" charset="-120"/>
+              </a:rPr>
+              <a:t>A public, intentionally-vulnerable Node.js reference application — small enough to inspect by hand, well known enough for an external sanity check.</a:t>
+            </a:r>
+            <a:endParaRPr lang="en-US" sz="1200" dirty="0"/>
           </a:p>
         </p:txBody>
       </p:sp>
       <p:pic>
         <p:nvPicPr>
-          <p:cNvPr id="4" name="Image 0" descr="../results/benchmark_accuracy.png">    </p:cNvPr>
+          <p:cNvPr id="5" name="Image 0" descr="../results/ingestion_funnel.png">    </p:cNvPr>
           <p:cNvPicPr>
             <a:picLocks noChangeAspect="1"/>
           </p:cNvPicPr>
@@ -11060,46 +12346,48 @@
         </p:blipFill>
         <p:spPr>
           <a:xfrm>
-            <a:off x="548640" y="1371600"/>
-            <a:ext cx="5943600" cy="4160520"/>
+            <a:off x="457200" y="1965960"/>
+            <a:ext cx="5577840" cy="4206240"/>
           </a:xfrm>
           <a:prstGeom prst="rect">
             <a:avLst/>
           </a:prstGeom>
         </p:spPr>
       </p:pic>
-      <p:sp>
-        <p:nvSpPr>
-          <p:cNvPr id="5" name="Shape 2"/>
-          <p:cNvSpPr/>
-          <p:nvPr/>
-        </p:nvSpPr>
-        <p:spPr>
-          <a:xfrm>
-            <a:off x="6766560" y="1371600"/>
-            <a:ext cx="4892040" cy="1920240"/>
-          </a:xfrm>
-          <a:prstGeom prst="roundRect">
-            <a:avLst>
-              <a:gd name="adj" fmla="val 3810"/>
-            </a:avLst>
-          </a:prstGeom>
-          <a:solidFill>
-            <a:srgbClr val="EAF3F8"/>
-          </a:solidFill>
-          <a:ln/>
-        </p:spPr>
-      </p:sp>
-      <p:sp>
-        <p:nvSpPr>
-          <p:cNvPr id="6" name="Text 3"/>
-          <p:cNvSpPr/>
-          <p:nvPr/>
-        </p:nvSpPr>
-        <p:spPr>
-          <a:xfrm>
-            <a:off x="6995160" y="1508760"/>
-            <a:ext cx="4480560" cy="640080"/>
+      <p:pic>
+        <p:nvPicPr>
+          <p:cNvPr id="6" name="Image 1" descr="../results/chunking_timing.png">    </p:cNvPr>
+          <p:cNvPicPr>
+            <a:picLocks noChangeAspect="1"/>
+          </p:cNvPicPr>
+          <p:nvPr/>
+        </p:nvPicPr>
+        <p:blipFill>
+          <a:blip r:embed="rId2"/>
+          <a:stretch>
+            <a:fillRect/>
+          </a:stretch>
+        </p:blipFill>
+        <p:spPr>
+          <a:xfrm>
+            <a:off x="6172200" y="1965960"/>
+            <a:ext cx="5577840" cy="4206240"/>
+          </a:xfrm>
+          <a:prstGeom prst="rect">
+            <a:avLst/>
+          </a:prstGeom>
+        </p:spPr>
+      </p:pic>
+      <p:sp>
+        <p:nvSpPr>
+          <p:cNvPr id="7" name="Text 3"/>
+          <p:cNvSpPr/>
+          <p:nvPr/>
+        </p:nvSpPr>
+        <p:spPr>
+          <a:xfrm>
+            <a:off x="457200" y="6492240"/>
+            <a:ext cx="5486400" cy="274320"/>
           </a:xfrm>
           <a:prstGeom prst="rect">
             <a:avLst/>
@@ -11111,202 +12399,18 @@
           <a:bodyPr wrap="square" rtlCol="0" anchor="ctr"/>
           <a:lstStyle/>
           <a:p>
-            <a:pPr indent="0" marL="0">
-              <a:buNone/>
-            </a:pPr>
-            <a:r>
-              <a:rPr lang="en-US" sz="2800" b="1" dirty="0">
-                <a:solidFill>
-                  <a:srgbClr val="065A82"/>
-                </a:solidFill>
-                <a:latin typeface="Cambria" pitchFamily="34" charset="0"/>
-                <a:ea typeface="Cambria" pitchFamily="34" charset="-122"/>
-                <a:cs typeface="Cambria" pitchFamily="34" charset="-120"/>
-              </a:rPr>
-              <a:t>63.6% / 72.7%</a:t>
-            </a:r>
-            <a:endParaRPr lang="en-US" sz="2800" dirty="0"/>
-          </a:p>
-        </p:txBody>
-      </p:sp>
-      <p:sp>
-        <p:nvSpPr>
-          <p:cNvPr id="7" name="Text 4"/>
-          <p:cNvSpPr/>
-          <p:nvPr/>
-        </p:nvSpPr>
-        <p:spPr>
-          <a:xfrm>
-            <a:off x="6995160" y="2148840"/>
-            <a:ext cx="4480560" cy="1005840"/>
-          </a:xfrm>
-          <a:prstGeom prst="rect">
-            <a:avLst/>
-          </a:prstGeom>
-          <a:noFill/>
-          <a:ln/>
-        </p:spPr>
-        <p:txBody>
-          <a:bodyPr wrap="square" rtlCol="0" anchor="ctr"/>
-          <a:lstStyle/>
-          <a:p>
-            <a:pPr indent="0" marL="0">
-              <a:lnSpc>
-                <a:spcPct val="125000"/>
-              </a:lnSpc>
-              <a:buNone/>
-            </a:pPr>
-            <a:r>
-              <a:rPr lang="en-US" sz="1150" dirty="0">
-                <a:solidFill>
-                  <a:srgbClr val="333F4E"/>
+            <a:pPr algn="l" indent="0" marL="0">
+              <a:buNone/>
+            </a:pPr>
+            <a:r>
+              <a:rPr lang="en-US" sz="900" dirty="0">
+                <a:solidFill>
+                  <a:srgbClr val="5B6472"/>
                 </a:solidFill>
                 <a:latin typeface="Calibri" pitchFamily="34" charset="0"/>
                 <a:ea typeface="Calibri" pitchFamily="34" charset="-122"/>
                 <a:cs typeface="Calibri" pitchFamily="34" charset="-120"/>
               </a:rPr>
-              <a:t>Top-1 / Top-3 retrieval accuracy against ground-truth CWE labels, using the IDF-weighted embedding actually shipped in the pipeline</a:t>
-            </a:r>
-            <a:endParaRPr lang="en-US" sz="1150" dirty="0"/>
-          </a:p>
-        </p:txBody>
-      </p:sp>
-      <p:sp>
-        <p:nvSpPr>
-          <p:cNvPr id="8" name="Shape 5"/>
-          <p:cNvSpPr/>
-          <p:nvPr/>
-        </p:nvSpPr>
-        <p:spPr>
-          <a:xfrm>
-            <a:off x="6766560" y="3520440"/>
-            <a:ext cx="4892040" cy="2011680"/>
-          </a:xfrm>
-          <a:prstGeom prst="roundRect">
-            <a:avLst>
-              <a:gd name="adj" fmla="val 3636"/>
-            </a:avLst>
-          </a:prstGeom>
-          <a:solidFill>
-            <a:srgbClr val="FBEDE8"/>
-          </a:solidFill>
-          <a:ln/>
-        </p:spPr>
-      </p:sp>
-      <p:sp>
-        <p:nvSpPr>
-          <p:cNvPr id="9" name="Text 6"/>
-          <p:cNvSpPr/>
-          <p:nvPr/>
-        </p:nvSpPr>
-        <p:spPr>
-          <a:xfrm>
-            <a:off x="6995160" y="3657600"/>
-            <a:ext cx="4480560" cy="320040"/>
-          </a:xfrm>
-          <a:prstGeom prst="rect">
-            <a:avLst/>
-          </a:prstGeom>
-          <a:noFill/>
-          <a:ln/>
-        </p:spPr>
-        <p:txBody>
-          <a:bodyPr wrap="square" rtlCol="0" anchor="ctr"/>
-          <a:lstStyle/>
-          <a:p>
-            <a:pPr indent="0" marL="0">
-              <a:buNone/>
-            </a:pPr>
-            <a:r>
-              <a:rPr lang="en-US" sz="1250" b="1" dirty="0">
-                <a:solidFill>
-                  <a:srgbClr val="B03A2E"/>
-                </a:solidFill>
-                <a:latin typeface="Calibri" pitchFamily="34" charset="0"/>
-                <a:ea typeface="Calibri" pitchFamily="34" charset="-122"/>
-                <a:cs typeface="Calibri" pitchFamily="34" charset="-120"/>
-              </a:rPr>
-              <a:t>Where it still struggles</a:t>
-            </a:r>
-            <a:endParaRPr lang="en-US" sz="1250" dirty="0"/>
-          </a:p>
-        </p:txBody>
-      </p:sp>
-      <p:sp>
-        <p:nvSpPr>
-          <p:cNvPr id="10" name="Text 7"/>
-          <p:cNvSpPr/>
-          <p:nvPr/>
-        </p:nvSpPr>
-        <p:spPr>
-          <a:xfrm>
-            <a:off x="6995160" y="4023360"/>
-            <a:ext cx="4480560" cy="1417320"/>
-          </a:xfrm>
-          <a:prstGeom prst="rect">
-            <a:avLst/>
-          </a:prstGeom>
-          <a:noFill/>
-          <a:ln/>
-        </p:spPr>
-        <p:txBody>
-          <a:bodyPr wrap="square" rtlCol="0" anchor="ctr"/>
-          <a:lstStyle/>
-          <a:p>
-            <a:pPr indent="0" marL="0">
-              <a:lnSpc>
-                <a:spcPct val="122000"/>
-              </a:lnSpc>
-              <a:buNone/>
-            </a:pPr>
-            <a:r>
-              <a:rPr lang="en-US" sz="1080" dirty="0">
-                <a:solidFill>
-                  <a:srgbClr val="333F4E"/>
-                </a:solidFill>
-                <a:latin typeface="Calibri" pitchFamily="34" charset="0"/>
-                <a:ea typeface="Calibri" pitchFamily="34" charset="-122"/>
-                <a:cs typeface="Calibri" pitchFamily="34" charset="-120"/>
-              </a:rPr>
-              <a:t>Closely related access-control weaknesses (Missing/Incorrect Authorization, IDOR, Broken Access Control) — these differ on facts a word-frequency model can't see (is a check present at all, or present but wrong?). This is the specific, motivated target for the Review 4 LLM reasoning step.</a:t>
-            </a:r>
-            <a:endParaRPr lang="en-US" sz="1080" dirty="0"/>
-          </a:p>
-        </p:txBody>
-      </p:sp>
-      <p:sp>
-        <p:nvSpPr>
-          <p:cNvPr id="11" name="Text 8"/>
-          <p:cNvSpPr/>
-          <p:nvPr/>
-        </p:nvSpPr>
-        <p:spPr>
-          <a:xfrm>
-            <a:off x="457200" y="6492240"/>
-            <a:ext cx="5486400" cy="274320"/>
-          </a:xfrm>
-          <a:prstGeom prst="rect">
-            <a:avLst/>
-          </a:prstGeom>
-          <a:noFill/>
-          <a:ln/>
-        </p:spPr>
-        <p:txBody>
-          <a:bodyPr wrap="square" rtlCol="0" anchor="ctr"/>
-          <a:lstStyle/>
-          <a:p>
-            <a:pPr algn="l" indent="0" marL="0">
-              <a:buNone/>
-            </a:pPr>
-            <a:r>
-              <a:rPr lang="en-US" sz="900" dirty="0">
-                <a:solidFill>
-                  <a:srgbClr val="5B6472"/>
-                </a:solidFill>
-                <a:latin typeface="Calibri" pitchFamily="34" charset="0"/>
-                <a:ea typeface="Calibri" pitchFamily="34" charset="-122"/>
-                <a:cs typeface="Calibri" pitchFamily="34" charset="-120"/>
-              </a:rPr>
               <a:t>BCSE497J · Project I · Review 3</a:t>
             </a:r>
             <a:endParaRPr lang="en-US" sz="900" dirty="0"/>
@@ -11315,7 +12419,7 @@
       </p:sp>
       <p:sp>
         <p:nvSpPr>
-          <p:cNvPr id="12" name="Text 9"/>
+          <p:cNvPr id="8" name="Text 4"/>
           <p:cNvSpPr/>
           <p:nvPr/>
         </p:nvSpPr>

</xml_diff>